<commit_message>
UI: rename forecast model dropdown to user-friendly names
</commit_message>
<xml_diff>
--- a/InvenVision_Pitch.pptx
+++ b/InvenVision_Pitch.pptx
@@ -16,7 +16,6 @@
     <p:sldId id="264" r:id="rId15"/>
     <p:sldId id="265" r:id="rId16"/>
     <p:sldId id="266" r:id="rId17"/>
-    <p:sldId id="267" r:id="rId18"/>
   </p:sldIdLst>
   <p:sldSz cx="12188952" cy="6858000" type="screen4x3"/>
   <p:notesSz cx="6858000" cy="9144000"/>
@@ -3248,7 +3247,7 @@
                   <a:srgbClr val="00D4FF"/>
                 </a:solidFill>
               </a:rPr>
-              <a:t>AI-Powered Pharmacy Inventory Intelligence</a:t>
+              <a:t>AI-Powered Inventory Intelligence for Every Business</a:t>
             </a:r>
           </a:p>
         </p:txBody>
@@ -3282,7 +3281,7 @@
                   <a:srgbClr val="B0BEC5"/>
                 </a:solidFill>
               </a:rPr>
-              <a:t>Predict · Manage · Never Run Out</a:t>
+              <a:t>Predict  ·  Manage  ·  Never Run Out</a:t>
             </a:r>
           </a:p>
         </p:txBody>
@@ -3440,7 +3439,7 @@
             <a:avLst/>
           </a:prstGeom>
           <a:solidFill>
-            <a:srgbClr val="00FF9D"/>
+            <a:srgbClr val="00D4FF"/>
           </a:solidFill>
           <a:ln>
             <a:noFill/>
@@ -3483,7 +3482,7 @@
             <a:avLst/>
           </a:prstGeom>
           <a:solidFill>
-            <a:srgbClr val="00FF9D"/>
+            <a:srgbClr val="00D4FF"/>
           </a:solidFill>
           <a:ln>
             <a:noFill/>
@@ -3535,12 +3534,12 @@
           <a:p>
             <a:pPr algn="l"/>
             <a:r>
-              <a:rPr sz="3400" b="1">
+              <a:rPr sz="3800" b="1">
                 <a:solidFill>
                   <a:srgbClr val="FFFFFF"/>
                 </a:solidFill>
               </a:rPr>
-              <a:t>Business Impact &amp; Market Opportunity</a:t>
+              <a:t>Live &amp; Deployed — Right Now</a:t>
             </a:r>
           </a:p>
         </p:txBody>
@@ -3553,14 +3552,14 @@
         </p:nvSpPr>
         <p:spPr>
           <a:xfrm>
-            <a:off x="502920" y="1508760"/>
-            <a:ext cx="2606040" cy="1920240"/>
+            <a:off x="502920" y="1645920"/>
+            <a:ext cx="11155680" cy="822960"/>
           </a:xfrm>
           <a:prstGeom prst="rect">
             <a:avLst/>
           </a:prstGeom>
           <a:solidFill>
-            <a:srgbClr val="041810"/>
+            <a:srgbClr val="041422"/>
           </a:solidFill>
           <a:ln>
             <a:noFill/>
@@ -3596,28 +3595,28 @@
         </p:nvSpPr>
         <p:spPr>
           <a:xfrm>
-            <a:off x="640080" y="1645920"/>
-            <a:ext cx="2331720" cy="914400"/>
-          </a:xfrm>
-          <a:prstGeom prst="rect">
-            <a:avLst/>
-          </a:prstGeom>
-          <a:noFill/>
-        </p:spPr>
-        <p:txBody>
-          <a:bodyPr wrap="square">
-            <a:spAutoFit/>
-          </a:bodyPr>
-          <a:lstStyle/>
-          <a:p>
-            <a:pPr algn="ctr"/>
-            <a:r>
-              <a:rPr sz="3600" b="1">
-                <a:solidFill>
-                  <a:srgbClr val="00FF9D"/>
-                </a:solidFill>
-              </a:rPr>
-              <a:t>₹15,000</a:t>
+            <a:off x="731520" y="1783080"/>
+            <a:ext cx="2743200" cy="548640"/>
+          </a:xfrm>
+          <a:prstGeom prst="rect">
+            <a:avLst/>
+          </a:prstGeom>
+          <a:noFill/>
+        </p:spPr>
+        <p:txBody>
+          <a:bodyPr wrap="square">
+            <a:spAutoFit/>
+          </a:bodyPr>
+          <a:lstStyle/>
+          <a:p>
+            <a:pPr algn="l"/>
+            <a:r>
+              <a:rPr sz="1600" b="1">
+                <a:solidFill>
+                  <a:srgbClr val="00D4FF"/>
+                </a:solidFill>
+              </a:rPr>
+              <a:t>🌐  Live App</a:t>
             </a:r>
           </a:p>
         </p:txBody>
@@ -3630,29 +3629,28 @@
         </p:nvSpPr>
         <p:spPr>
           <a:xfrm>
-            <a:off x="640080" y="2542032"/>
-            <a:ext cx="2331720" cy="731520"/>
-          </a:xfrm>
-          <a:prstGeom prst="rect">
-            <a:avLst/>
-          </a:prstGeom>
-          <a:noFill/>
-        </p:spPr>
-        <p:txBody>
-          <a:bodyPr wrap="square">
-            <a:spAutoFit/>
-          </a:bodyPr>
-          <a:lstStyle/>
-          <a:p>
-            <a:pPr algn="ctr"/>
-            <a:r>
-              <a:rPr sz="1300" b="0">
-                <a:solidFill>
-                  <a:srgbClr val="B0BEC5"/>
-                </a:solidFill>
-              </a:rPr>
-              <a:t>Saved per pharmacy
-per year from expiry prevention</a:t>
+            <a:off x="3566160" y="1828800"/>
+            <a:ext cx="7955279" cy="457200"/>
+          </a:xfrm>
+          <a:prstGeom prst="rect">
+            <a:avLst/>
+          </a:prstGeom>
+          <a:noFill/>
+        </p:spPr>
+        <p:txBody>
+          <a:bodyPr wrap="square">
+            <a:spAutoFit/>
+          </a:bodyPr>
+          <a:lstStyle/>
+          <a:p>
+            <a:pPr algn="l"/>
+            <a:r>
+              <a:rPr sz="1500" b="0">
+                <a:solidFill>
+                  <a:srgbClr val="FFFFFF"/>
+                </a:solidFill>
+              </a:rPr>
+              <a:t>gdsc-hackathon.up.railway.app</a:t>
             </a:r>
           </a:p>
         </p:txBody>
@@ -3665,14 +3663,14 @@
         </p:nvSpPr>
         <p:spPr>
           <a:xfrm>
-            <a:off x="3337560" y="1508760"/>
-            <a:ext cx="2606040" cy="1920240"/>
+            <a:off x="502920" y="2651760"/>
+            <a:ext cx="11155680" cy="822960"/>
           </a:xfrm>
           <a:prstGeom prst="rect">
             <a:avLst/>
           </a:prstGeom>
           <a:solidFill>
-            <a:srgbClr val="041810"/>
+            <a:srgbClr val="041422"/>
           </a:solidFill>
           <a:ln>
             <a:noFill/>
@@ -3708,28 +3706,28 @@
         </p:nvSpPr>
         <p:spPr>
           <a:xfrm>
-            <a:off x="3474720" y="1645920"/>
-            <a:ext cx="2331720" cy="914400"/>
-          </a:xfrm>
-          <a:prstGeom prst="rect">
-            <a:avLst/>
-          </a:prstGeom>
-          <a:noFill/>
-        </p:spPr>
-        <p:txBody>
-          <a:bodyPr wrap="square">
-            <a:spAutoFit/>
-          </a:bodyPr>
-          <a:lstStyle/>
-          <a:p>
-            <a:pPr algn="ctr"/>
-            <a:r>
-              <a:rPr sz="3600" b="1">
-                <a:solidFill>
-                  <a:srgbClr val="00D4FF"/>
-                </a:solidFill>
-              </a:rPr>
-              <a:t>30%</a:t>
+            <a:off x="731520" y="2788920"/>
+            <a:ext cx="2743200" cy="548640"/>
+          </a:xfrm>
+          <a:prstGeom prst="rect">
+            <a:avLst/>
+          </a:prstGeom>
+          <a:noFill/>
+        </p:spPr>
+        <p:txBody>
+          <a:bodyPr wrap="square">
+            <a:spAutoFit/>
+          </a:bodyPr>
+          <a:lstStyle/>
+          <a:p>
+            <a:pPr algn="l"/>
+            <a:r>
+              <a:rPr sz="1600" b="1">
+                <a:solidFill>
+                  <a:srgbClr val="00FF9D"/>
+                </a:solidFill>
+              </a:rPr>
+              <a:t>💚  Health Check</a:t>
             </a:r>
           </a:p>
         </p:txBody>
@@ -3742,29 +3740,28 @@
         </p:nvSpPr>
         <p:spPr>
           <a:xfrm>
-            <a:off x="3474720" y="2542032"/>
-            <a:ext cx="2331720" cy="731520"/>
-          </a:xfrm>
-          <a:prstGeom prst="rect">
-            <a:avLst/>
-          </a:prstGeom>
-          <a:noFill/>
-        </p:spPr>
-        <p:txBody>
-          <a:bodyPr wrap="square">
-            <a:spAutoFit/>
-          </a:bodyPr>
-          <a:lstStyle/>
-          <a:p>
-            <a:pPr algn="ctr"/>
-            <a:r>
-              <a:rPr sz="1300" b="0">
-                <a:solidFill>
-                  <a:srgbClr val="B0BEC5"/>
-                </a:solidFill>
-              </a:rPr>
-              <a:t>Reduction in stockout
-events with AI forecasting</a:t>
+            <a:off x="3566160" y="2834640"/>
+            <a:ext cx="7955279" cy="457200"/>
+          </a:xfrm>
+          <a:prstGeom prst="rect">
+            <a:avLst/>
+          </a:prstGeom>
+          <a:noFill/>
+        </p:spPr>
+        <p:txBody>
+          <a:bodyPr wrap="square">
+            <a:spAutoFit/>
+          </a:bodyPr>
+          <a:lstStyle/>
+          <a:p>
+            <a:pPr algn="l"/>
+            <a:r>
+              <a:rPr sz="1500" b="0">
+                <a:solidFill>
+                  <a:srgbClr val="FFFFFF"/>
+                </a:solidFill>
+              </a:rPr>
+              <a:t>gdsc-hackathon.up.railway.app/api/health</a:t>
             </a:r>
           </a:p>
         </p:txBody>
@@ -3777,14 +3774,14 @@
         </p:nvSpPr>
         <p:spPr>
           <a:xfrm>
-            <a:off x="6172200" y="1508760"/>
-            <a:ext cx="2606040" cy="1920240"/>
+            <a:off x="502920" y="3657600"/>
+            <a:ext cx="11155680" cy="822960"/>
           </a:xfrm>
           <a:prstGeom prst="rect">
             <a:avLst/>
           </a:prstGeom>
           <a:solidFill>
-            <a:srgbClr val="041810"/>
+            <a:srgbClr val="041422"/>
           </a:solidFill>
           <a:ln>
             <a:noFill/>
@@ -3820,28 +3817,28 @@
         </p:nvSpPr>
         <p:spPr>
           <a:xfrm>
-            <a:off x="6309360" y="1645920"/>
-            <a:ext cx="2331720" cy="914400"/>
-          </a:xfrm>
-          <a:prstGeom prst="rect">
-            <a:avLst/>
-          </a:prstGeom>
-          <a:noFill/>
-        </p:spPr>
-        <p:txBody>
-          <a:bodyPr wrap="square">
-            <a:spAutoFit/>
-          </a:bodyPr>
-          <a:lstStyle/>
-          <a:p>
-            <a:pPr algn="ctr"/>
-            <a:r>
-              <a:rPr sz="3600" b="1">
+            <a:off x="731520" y="3794760"/>
+            <a:ext cx="2743200" cy="548640"/>
+          </a:xfrm>
+          <a:prstGeom prst="rect">
+            <a:avLst/>
+          </a:prstGeom>
+          <a:noFill/>
+        </p:spPr>
+        <p:txBody>
+          <a:bodyPr wrap="square">
+            <a:spAutoFit/>
+          </a:bodyPr>
+          <a:lstStyle/>
+          <a:p>
+            <a:pPr algn="l"/>
+            <a:r>
+              <a:rPr sz="1600" b="1">
                 <a:solidFill>
                   <a:srgbClr val="FFD600"/>
                 </a:solidFill>
               </a:rPr>
-              <a:t>₹499/mo</a:t>
+              <a:t>💻  Source Code</a:t>
             </a:r>
           </a:p>
         </p:txBody>
@@ -3854,29 +3851,28 @@
         </p:nvSpPr>
         <p:spPr>
           <a:xfrm>
-            <a:off x="6309360" y="2542032"/>
-            <a:ext cx="2331720" cy="731520"/>
-          </a:xfrm>
-          <a:prstGeom prst="rect">
-            <a:avLst/>
-          </a:prstGeom>
-          <a:noFill/>
-        </p:spPr>
-        <p:txBody>
-          <a:bodyPr wrap="square">
-            <a:spAutoFit/>
-          </a:bodyPr>
-          <a:lstStyle/>
-          <a:p>
-            <a:pPr algn="ctr"/>
-            <a:r>
-              <a:rPr sz="1300" b="0">
-                <a:solidFill>
-                  <a:srgbClr val="B0BEC5"/>
-                </a:solidFill>
-              </a:rPr>
-              <a:t>Pro plan — affordable
-for every pharmacy</a:t>
+            <a:off x="3566160" y="3840480"/>
+            <a:ext cx="7955279" cy="457200"/>
+          </a:xfrm>
+          <a:prstGeom prst="rect">
+            <a:avLst/>
+          </a:prstGeom>
+          <a:noFill/>
+        </p:spPr>
+        <p:txBody>
+          <a:bodyPr wrap="square">
+            <a:spAutoFit/>
+          </a:bodyPr>
+          <a:lstStyle/>
+          <a:p>
+            <a:pPr algn="l"/>
+            <a:r>
+              <a:rPr sz="1500" b="0">
+                <a:solidFill>
+                  <a:srgbClr val="FFFFFF"/>
+                </a:solidFill>
+              </a:rPr>
+              <a:t>github.com/ansajkhare-ops/GDSC-INVENVISION</a:t>
             </a:r>
           </a:p>
         </p:txBody>
@@ -3889,14 +3885,14 @@
         </p:nvSpPr>
         <p:spPr>
           <a:xfrm>
-            <a:off x="9006840" y="1508760"/>
-            <a:ext cx="2606040" cy="1920240"/>
+            <a:off x="502920" y="4663440"/>
+            <a:ext cx="11155680" cy="822960"/>
           </a:xfrm>
           <a:prstGeom prst="rect">
             <a:avLst/>
           </a:prstGeom>
           <a:solidFill>
-            <a:srgbClr val="041810"/>
+            <a:srgbClr val="041422"/>
           </a:solidFill>
           <a:ln>
             <a:noFill/>
@@ -3932,28 +3928,28 @@
         </p:nvSpPr>
         <p:spPr>
           <a:xfrm>
-            <a:off x="9144000" y="1645920"/>
-            <a:ext cx="2331720" cy="914400"/>
-          </a:xfrm>
-          <a:prstGeom prst="rect">
-            <a:avLst/>
-          </a:prstGeom>
-          <a:noFill/>
-        </p:spPr>
-        <p:txBody>
-          <a:bodyPr wrap="square">
-            <a:spAutoFit/>
-          </a:bodyPr>
-          <a:lstStyle/>
-          <a:p>
-            <a:pPr algn="ctr"/>
-            <a:r>
-              <a:rPr sz="3600" b="1">
+            <a:off x="731520" y="4800600"/>
+            <a:ext cx="2743200" cy="548640"/>
+          </a:xfrm>
+          <a:prstGeom prst="rect">
+            <a:avLst/>
+          </a:prstGeom>
+          <a:noFill/>
+        </p:spPr>
+        <p:txBody>
+          <a:bodyPr wrap="square">
+            <a:spAutoFit/>
+          </a:bodyPr>
+          <a:lstStyle/>
+          <a:p>
+            <a:pPr algn="l"/>
+            <a:r>
+              <a:rPr sz="1600" b="1">
                 <a:solidFill>
                   <a:srgbClr val="FF6B35"/>
                 </a:solidFill>
               </a:rPr>
-              <a:t>9L+</a:t>
+              <a:t>🗄️  Database</a:t>
             </a:r>
           </a:p>
         </p:txBody>
@@ -3966,29 +3962,28 @@
         </p:nvSpPr>
         <p:spPr>
           <a:xfrm>
-            <a:off x="9144000" y="2542032"/>
-            <a:ext cx="2331720" cy="731520"/>
-          </a:xfrm>
-          <a:prstGeom prst="rect">
-            <a:avLst/>
-          </a:prstGeom>
-          <a:noFill/>
-        </p:spPr>
-        <p:txBody>
-          <a:bodyPr wrap="square">
-            <a:spAutoFit/>
-          </a:bodyPr>
-          <a:lstStyle/>
-          <a:p>
-            <a:pPr algn="ctr"/>
-            <a:r>
-              <a:rPr sz="1300" b="0">
-                <a:solidFill>
-                  <a:srgbClr val="B0BEC5"/>
-                </a:solidFill>
-              </a:rPr>
-              <a:t>Target pharmacies
-across India</a:t>
+            <a:off x="3566160" y="4846320"/>
+            <a:ext cx="7955279" cy="457200"/>
+          </a:xfrm>
+          <a:prstGeom prst="rect">
+            <a:avLst/>
+          </a:prstGeom>
+          <a:noFill/>
+        </p:spPr>
+        <p:txBody>
+          <a:bodyPr wrap="square">
+            <a:spAutoFit/>
+          </a:bodyPr>
+          <a:lstStyle/>
+          <a:p>
+            <a:pPr algn="l"/>
+            <a:r>
+              <a:rPr sz="1500" b="0">
+                <a:solidFill>
+                  <a:srgbClr val="FFFFFF"/>
+                </a:solidFill>
+              </a:rPr>
+              <a:t>Supabase — aws-1-ap-southeast-1 (PostgreSQL)</a:t>
             </a:r>
           </a:p>
         </p:txBody>
@@ -4001,14 +3996,14 @@
         </p:nvSpPr>
         <p:spPr>
           <a:xfrm>
-            <a:off x="502920" y="3794760"/>
-            <a:ext cx="11155680" cy="640080"/>
+            <a:off x="502920" y="5806440"/>
+            <a:ext cx="11155680" cy="594360"/>
           </a:xfrm>
           <a:prstGeom prst="rect">
             <a:avLst/>
           </a:prstGeom>
           <a:solidFill>
-            <a:srgbClr val="041810"/>
+            <a:srgbClr val="002510"/>
           </a:solidFill>
           <a:ln>
             <a:noFill/>
@@ -4044,96 +4039,28 @@
         </p:nvSpPr>
         <p:spPr>
           <a:xfrm>
-            <a:off x="731520" y="3858768"/>
-            <a:ext cx="10789920" cy="502920"/>
-          </a:xfrm>
-          <a:prstGeom prst="rect">
-            <a:avLst/>
-          </a:prstGeom>
-          <a:noFill/>
-        </p:spPr>
-        <p:txBody>
-          <a:bodyPr wrap="square">
-            <a:spAutoFit/>
-          </a:bodyPr>
-          <a:lstStyle/>
-          <a:p>
-            <a:pPr algn="ctr"/>
-            <a:r>
-              <a:rPr sz="1600" b="1">
+            <a:off x="731520" y="5870448"/>
+            <a:ext cx="10789920" cy="457200"/>
+          </a:xfrm>
+          <a:prstGeom prst="rect">
+            <a:avLst/>
+          </a:prstGeom>
+          <a:noFill/>
+        </p:spPr>
+        <p:txBody>
+          <a:bodyPr wrap="square">
+            <a:spAutoFit/>
+          </a:bodyPr>
+          <a:lstStyle/>
+          <a:p>
+            <a:pPr algn="ctr"/>
+            <a:r>
+              <a:rPr sz="1500" b="1">
                 <a:solidFill>
                   <a:srgbClr val="00FF9D"/>
                 </a:solidFill>
               </a:rPr>
-              <a:t>🎯  Revenue Potential:  1% adoption × 9L pharmacies × ₹499/month  =  ₹4.5 Crore MRR</a:t>
-            </a:r>
-          </a:p>
-        </p:txBody>
-      </p:sp>
-      <p:sp>
-        <p:nvSpPr>
-          <p:cNvPr id="20" name="TextBox 19"/>
-          <p:cNvSpPr txBox="1"/>
-          <p:nvPr/>
-        </p:nvSpPr>
-        <p:spPr>
-          <a:xfrm>
-            <a:off x="640080" y="4754880"/>
-            <a:ext cx="2743200" cy="365760"/>
-          </a:xfrm>
-          <a:prstGeom prst="rect">
-            <a:avLst/>
-          </a:prstGeom>
-          <a:noFill/>
-        </p:spPr>
-        <p:txBody>
-          <a:bodyPr wrap="square">
-            <a:spAutoFit/>
-          </a:bodyPr>
-          <a:lstStyle/>
-          <a:p>
-            <a:pPr algn="l"/>
-            <a:r>
-              <a:rPr sz="1600" b="1">
-                <a:solidFill>
-                  <a:srgbClr val="FFFFFF"/>
-                </a:solidFill>
-              </a:rPr>
-              <a:t>Roadmap:</a:t>
-            </a:r>
-          </a:p>
-        </p:txBody>
-      </p:sp>
-      <p:sp>
-        <p:nvSpPr>
-          <p:cNvPr id="21" name="TextBox 20"/>
-          <p:cNvSpPr txBox="1"/>
-          <p:nvPr/>
-        </p:nvSpPr>
-        <p:spPr>
-          <a:xfrm>
-            <a:off x="640080" y="5166360"/>
-            <a:ext cx="10972800" cy="457200"/>
-          </a:xfrm>
-          <a:prstGeom prst="rect">
-            <a:avLst/>
-          </a:prstGeom>
-          <a:noFill/>
-        </p:spPr>
-        <p:txBody>
-          <a:bodyPr wrap="square">
-            <a:spAutoFit/>
-          </a:bodyPr>
-          <a:lstStyle/>
-          <a:p>
-            <a:pPr algn="l"/>
-            <a:r>
-              <a:rPr sz="1400" b="0">
-                <a:solidFill>
-                  <a:srgbClr val="B0BEC5"/>
-                </a:solidFill>
-              </a:rPr>
-              <a:t>📱 PWA / Offline Mode  →  💬 WhatsApp Alerts  →  🤖 GPT-powered Reorder Advisor  →  🏥 Multi-branch Support</a:t>
+              <a:t>✅  Not a prototype. Not a mockup. A real, production-deployed application.</a:t>
             </a:r>
           </a:p>
         </p:txBody>
@@ -4250,8 +4177,8 @@
         </p:nvSpPr>
         <p:spPr>
           <a:xfrm>
-            <a:off x="640080" y="502920"/>
-            <a:ext cx="1005840" cy="64008"/>
+            <a:off x="0" y="6784848"/>
+            <a:ext cx="12188952" cy="73152"/>
           </a:xfrm>
           <a:prstGeom prst="rect">
             <a:avLst/>
@@ -4293,708 +4220,6 @@
         </p:nvSpPr>
         <p:spPr>
           <a:xfrm>
-            <a:off x="640080" y="548640"/>
-            <a:ext cx="10972800" cy="640080"/>
-          </a:xfrm>
-          <a:prstGeom prst="rect">
-            <a:avLst/>
-          </a:prstGeom>
-          <a:noFill/>
-        </p:spPr>
-        <p:txBody>
-          <a:bodyPr wrap="square">
-            <a:spAutoFit/>
-          </a:bodyPr>
-          <a:lstStyle/>
-          <a:p>
-            <a:pPr algn="l"/>
-            <a:r>
-              <a:rPr sz="3800" b="1">
-                <a:solidFill>
-                  <a:srgbClr val="FFFFFF"/>
-                </a:solidFill>
-              </a:rPr>
-              <a:t>Live &amp; Deployed — Right Now</a:t>
-            </a:r>
-          </a:p>
-        </p:txBody>
-      </p:sp>
-      <p:sp>
-        <p:nvSpPr>
-          <p:cNvPr id="6" name="Rectangle 5"/>
-          <p:cNvSpPr/>
-          <p:nvPr/>
-        </p:nvSpPr>
-        <p:spPr>
-          <a:xfrm>
-            <a:off x="502920" y="1645920"/>
-            <a:ext cx="11155680" cy="822960"/>
-          </a:xfrm>
-          <a:prstGeom prst="rect">
-            <a:avLst/>
-          </a:prstGeom>
-          <a:solidFill>
-            <a:srgbClr val="041422"/>
-          </a:solidFill>
-          <a:ln>
-            <a:noFill/>
-          </a:ln>
-        </p:spPr>
-        <p:style>
-          <a:lnRef idx="1">
-            <a:schemeClr val="accent1"/>
-          </a:lnRef>
-          <a:fillRef idx="3">
-            <a:schemeClr val="accent1"/>
-          </a:fillRef>
-          <a:effectRef idx="2">
-            <a:schemeClr val="accent1"/>
-          </a:effectRef>
-          <a:fontRef idx="minor">
-            <a:schemeClr val="lt1"/>
-          </a:fontRef>
-        </p:style>
-        <p:txBody>
-          <a:bodyPr rtlCol="0" anchor="ctr"/>
-          <a:lstStyle/>
-          <a:p>
-            <a:pPr algn="ctr"/>
-          </a:p>
-        </p:txBody>
-      </p:sp>
-      <p:sp>
-        <p:nvSpPr>
-          <p:cNvPr id="7" name="TextBox 6"/>
-          <p:cNvSpPr txBox="1"/>
-          <p:nvPr/>
-        </p:nvSpPr>
-        <p:spPr>
-          <a:xfrm>
-            <a:off x="731520" y="1783080"/>
-            <a:ext cx="2743200" cy="548640"/>
-          </a:xfrm>
-          <a:prstGeom prst="rect">
-            <a:avLst/>
-          </a:prstGeom>
-          <a:noFill/>
-        </p:spPr>
-        <p:txBody>
-          <a:bodyPr wrap="square">
-            <a:spAutoFit/>
-          </a:bodyPr>
-          <a:lstStyle/>
-          <a:p>
-            <a:pPr algn="l"/>
-            <a:r>
-              <a:rPr sz="1600" b="1">
-                <a:solidFill>
-                  <a:srgbClr val="00D4FF"/>
-                </a:solidFill>
-              </a:rPr>
-              <a:t>🌐  Live App</a:t>
-            </a:r>
-          </a:p>
-        </p:txBody>
-      </p:sp>
-      <p:sp>
-        <p:nvSpPr>
-          <p:cNvPr id="8" name="TextBox 7"/>
-          <p:cNvSpPr txBox="1"/>
-          <p:nvPr/>
-        </p:nvSpPr>
-        <p:spPr>
-          <a:xfrm>
-            <a:off x="3566160" y="1828800"/>
-            <a:ext cx="7955279" cy="457200"/>
-          </a:xfrm>
-          <a:prstGeom prst="rect">
-            <a:avLst/>
-          </a:prstGeom>
-          <a:noFill/>
-        </p:spPr>
-        <p:txBody>
-          <a:bodyPr wrap="square">
-            <a:spAutoFit/>
-          </a:bodyPr>
-          <a:lstStyle/>
-          <a:p>
-            <a:pPr algn="l"/>
-            <a:r>
-              <a:rPr sz="1500" b="0">
-                <a:solidFill>
-                  <a:srgbClr val="FFFFFF"/>
-                </a:solidFill>
-              </a:rPr>
-              <a:t>gdsc-hackathon.up.railway.app</a:t>
-            </a:r>
-          </a:p>
-        </p:txBody>
-      </p:sp>
-      <p:sp>
-        <p:nvSpPr>
-          <p:cNvPr id="9" name="Rectangle 8"/>
-          <p:cNvSpPr/>
-          <p:nvPr/>
-        </p:nvSpPr>
-        <p:spPr>
-          <a:xfrm>
-            <a:off x="502920" y="2651760"/>
-            <a:ext cx="11155680" cy="822960"/>
-          </a:xfrm>
-          <a:prstGeom prst="rect">
-            <a:avLst/>
-          </a:prstGeom>
-          <a:solidFill>
-            <a:srgbClr val="041422"/>
-          </a:solidFill>
-          <a:ln>
-            <a:noFill/>
-          </a:ln>
-        </p:spPr>
-        <p:style>
-          <a:lnRef idx="1">
-            <a:schemeClr val="accent1"/>
-          </a:lnRef>
-          <a:fillRef idx="3">
-            <a:schemeClr val="accent1"/>
-          </a:fillRef>
-          <a:effectRef idx="2">
-            <a:schemeClr val="accent1"/>
-          </a:effectRef>
-          <a:fontRef idx="minor">
-            <a:schemeClr val="lt1"/>
-          </a:fontRef>
-        </p:style>
-        <p:txBody>
-          <a:bodyPr rtlCol="0" anchor="ctr"/>
-          <a:lstStyle/>
-          <a:p>
-            <a:pPr algn="ctr"/>
-          </a:p>
-        </p:txBody>
-      </p:sp>
-      <p:sp>
-        <p:nvSpPr>
-          <p:cNvPr id="10" name="TextBox 9"/>
-          <p:cNvSpPr txBox="1"/>
-          <p:nvPr/>
-        </p:nvSpPr>
-        <p:spPr>
-          <a:xfrm>
-            <a:off x="731520" y="2788920"/>
-            <a:ext cx="2743200" cy="548640"/>
-          </a:xfrm>
-          <a:prstGeom prst="rect">
-            <a:avLst/>
-          </a:prstGeom>
-          <a:noFill/>
-        </p:spPr>
-        <p:txBody>
-          <a:bodyPr wrap="square">
-            <a:spAutoFit/>
-          </a:bodyPr>
-          <a:lstStyle/>
-          <a:p>
-            <a:pPr algn="l"/>
-            <a:r>
-              <a:rPr sz="1600" b="1">
-                <a:solidFill>
-                  <a:srgbClr val="00FF9D"/>
-                </a:solidFill>
-              </a:rPr>
-              <a:t>💚  Health Check</a:t>
-            </a:r>
-          </a:p>
-        </p:txBody>
-      </p:sp>
-      <p:sp>
-        <p:nvSpPr>
-          <p:cNvPr id="11" name="TextBox 10"/>
-          <p:cNvSpPr txBox="1"/>
-          <p:nvPr/>
-        </p:nvSpPr>
-        <p:spPr>
-          <a:xfrm>
-            <a:off x="3566160" y="2834640"/>
-            <a:ext cx="7955279" cy="457200"/>
-          </a:xfrm>
-          <a:prstGeom prst="rect">
-            <a:avLst/>
-          </a:prstGeom>
-          <a:noFill/>
-        </p:spPr>
-        <p:txBody>
-          <a:bodyPr wrap="square">
-            <a:spAutoFit/>
-          </a:bodyPr>
-          <a:lstStyle/>
-          <a:p>
-            <a:pPr algn="l"/>
-            <a:r>
-              <a:rPr sz="1500" b="0">
-                <a:solidFill>
-                  <a:srgbClr val="FFFFFF"/>
-                </a:solidFill>
-              </a:rPr>
-              <a:t>gdsc-hackathon.up.railway.app/api/health</a:t>
-            </a:r>
-          </a:p>
-        </p:txBody>
-      </p:sp>
-      <p:sp>
-        <p:nvSpPr>
-          <p:cNvPr id="12" name="Rectangle 11"/>
-          <p:cNvSpPr/>
-          <p:nvPr/>
-        </p:nvSpPr>
-        <p:spPr>
-          <a:xfrm>
-            <a:off x="502920" y="3657600"/>
-            <a:ext cx="11155680" cy="822960"/>
-          </a:xfrm>
-          <a:prstGeom prst="rect">
-            <a:avLst/>
-          </a:prstGeom>
-          <a:solidFill>
-            <a:srgbClr val="041422"/>
-          </a:solidFill>
-          <a:ln>
-            <a:noFill/>
-          </a:ln>
-        </p:spPr>
-        <p:style>
-          <a:lnRef idx="1">
-            <a:schemeClr val="accent1"/>
-          </a:lnRef>
-          <a:fillRef idx="3">
-            <a:schemeClr val="accent1"/>
-          </a:fillRef>
-          <a:effectRef idx="2">
-            <a:schemeClr val="accent1"/>
-          </a:effectRef>
-          <a:fontRef idx="minor">
-            <a:schemeClr val="lt1"/>
-          </a:fontRef>
-        </p:style>
-        <p:txBody>
-          <a:bodyPr rtlCol="0" anchor="ctr"/>
-          <a:lstStyle/>
-          <a:p>
-            <a:pPr algn="ctr"/>
-          </a:p>
-        </p:txBody>
-      </p:sp>
-      <p:sp>
-        <p:nvSpPr>
-          <p:cNvPr id="13" name="TextBox 12"/>
-          <p:cNvSpPr txBox="1"/>
-          <p:nvPr/>
-        </p:nvSpPr>
-        <p:spPr>
-          <a:xfrm>
-            <a:off x="731520" y="3794760"/>
-            <a:ext cx="2743200" cy="548640"/>
-          </a:xfrm>
-          <a:prstGeom prst="rect">
-            <a:avLst/>
-          </a:prstGeom>
-          <a:noFill/>
-        </p:spPr>
-        <p:txBody>
-          <a:bodyPr wrap="square">
-            <a:spAutoFit/>
-          </a:bodyPr>
-          <a:lstStyle/>
-          <a:p>
-            <a:pPr algn="l"/>
-            <a:r>
-              <a:rPr sz="1600" b="1">
-                <a:solidFill>
-                  <a:srgbClr val="FFD600"/>
-                </a:solidFill>
-              </a:rPr>
-              <a:t>💻  Source Code</a:t>
-            </a:r>
-          </a:p>
-        </p:txBody>
-      </p:sp>
-      <p:sp>
-        <p:nvSpPr>
-          <p:cNvPr id="14" name="TextBox 13"/>
-          <p:cNvSpPr txBox="1"/>
-          <p:nvPr/>
-        </p:nvSpPr>
-        <p:spPr>
-          <a:xfrm>
-            <a:off x="3566160" y="3840480"/>
-            <a:ext cx="7955279" cy="457200"/>
-          </a:xfrm>
-          <a:prstGeom prst="rect">
-            <a:avLst/>
-          </a:prstGeom>
-          <a:noFill/>
-        </p:spPr>
-        <p:txBody>
-          <a:bodyPr wrap="square">
-            <a:spAutoFit/>
-          </a:bodyPr>
-          <a:lstStyle/>
-          <a:p>
-            <a:pPr algn="l"/>
-            <a:r>
-              <a:rPr sz="1500" b="0">
-                <a:solidFill>
-                  <a:srgbClr val="FFFFFF"/>
-                </a:solidFill>
-              </a:rPr>
-              <a:t>github.com/ansajkhare-ops/GDSC-INVENVISION</a:t>
-            </a:r>
-          </a:p>
-        </p:txBody>
-      </p:sp>
-      <p:sp>
-        <p:nvSpPr>
-          <p:cNvPr id="15" name="Rectangle 14"/>
-          <p:cNvSpPr/>
-          <p:nvPr/>
-        </p:nvSpPr>
-        <p:spPr>
-          <a:xfrm>
-            <a:off x="502920" y="4663440"/>
-            <a:ext cx="11155680" cy="822960"/>
-          </a:xfrm>
-          <a:prstGeom prst="rect">
-            <a:avLst/>
-          </a:prstGeom>
-          <a:solidFill>
-            <a:srgbClr val="041422"/>
-          </a:solidFill>
-          <a:ln>
-            <a:noFill/>
-          </a:ln>
-        </p:spPr>
-        <p:style>
-          <a:lnRef idx="1">
-            <a:schemeClr val="accent1"/>
-          </a:lnRef>
-          <a:fillRef idx="3">
-            <a:schemeClr val="accent1"/>
-          </a:fillRef>
-          <a:effectRef idx="2">
-            <a:schemeClr val="accent1"/>
-          </a:effectRef>
-          <a:fontRef idx="minor">
-            <a:schemeClr val="lt1"/>
-          </a:fontRef>
-        </p:style>
-        <p:txBody>
-          <a:bodyPr rtlCol="0" anchor="ctr"/>
-          <a:lstStyle/>
-          <a:p>
-            <a:pPr algn="ctr"/>
-          </a:p>
-        </p:txBody>
-      </p:sp>
-      <p:sp>
-        <p:nvSpPr>
-          <p:cNvPr id="16" name="TextBox 15"/>
-          <p:cNvSpPr txBox="1"/>
-          <p:nvPr/>
-        </p:nvSpPr>
-        <p:spPr>
-          <a:xfrm>
-            <a:off x="731520" y="4800600"/>
-            <a:ext cx="2743200" cy="548640"/>
-          </a:xfrm>
-          <a:prstGeom prst="rect">
-            <a:avLst/>
-          </a:prstGeom>
-          <a:noFill/>
-        </p:spPr>
-        <p:txBody>
-          <a:bodyPr wrap="square">
-            <a:spAutoFit/>
-          </a:bodyPr>
-          <a:lstStyle/>
-          <a:p>
-            <a:pPr algn="l"/>
-            <a:r>
-              <a:rPr sz="1600" b="1">
-                <a:solidFill>
-                  <a:srgbClr val="FF6B35"/>
-                </a:solidFill>
-              </a:rPr>
-              <a:t>🗄️  Database</a:t>
-            </a:r>
-          </a:p>
-        </p:txBody>
-      </p:sp>
-      <p:sp>
-        <p:nvSpPr>
-          <p:cNvPr id="17" name="TextBox 16"/>
-          <p:cNvSpPr txBox="1"/>
-          <p:nvPr/>
-        </p:nvSpPr>
-        <p:spPr>
-          <a:xfrm>
-            <a:off x="3566160" y="4846320"/>
-            <a:ext cx="7955279" cy="457200"/>
-          </a:xfrm>
-          <a:prstGeom prst="rect">
-            <a:avLst/>
-          </a:prstGeom>
-          <a:noFill/>
-        </p:spPr>
-        <p:txBody>
-          <a:bodyPr wrap="square">
-            <a:spAutoFit/>
-          </a:bodyPr>
-          <a:lstStyle/>
-          <a:p>
-            <a:pPr algn="l"/>
-            <a:r>
-              <a:rPr sz="1500" b="0">
-                <a:solidFill>
-                  <a:srgbClr val="FFFFFF"/>
-                </a:solidFill>
-              </a:rPr>
-              <a:t>Supabase — aws-1-ap-southeast-1 (PostgreSQL)</a:t>
-            </a:r>
-          </a:p>
-        </p:txBody>
-      </p:sp>
-      <p:sp>
-        <p:nvSpPr>
-          <p:cNvPr id="18" name="Rectangle 17"/>
-          <p:cNvSpPr/>
-          <p:nvPr/>
-        </p:nvSpPr>
-        <p:spPr>
-          <a:xfrm>
-            <a:off x="502920" y="5806440"/>
-            <a:ext cx="11155680" cy="594360"/>
-          </a:xfrm>
-          <a:prstGeom prst="rect">
-            <a:avLst/>
-          </a:prstGeom>
-          <a:solidFill>
-            <a:srgbClr val="002510"/>
-          </a:solidFill>
-          <a:ln>
-            <a:noFill/>
-          </a:ln>
-        </p:spPr>
-        <p:style>
-          <a:lnRef idx="1">
-            <a:schemeClr val="accent1"/>
-          </a:lnRef>
-          <a:fillRef idx="3">
-            <a:schemeClr val="accent1"/>
-          </a:fillRef>
-          <a:effectRef idx="2">
-            <a:schemeClr val="accent1"/>
-          </a:effectRef>
-          <a:fontRef idx="minor">
-            <a:schemeClr val="lt1"/>
-          </a:fontRef>
-        </p:style>
-        <p:txBody>
-          <a:bodyPr rtlCol="0" anchor="ctr"/>
-          <a:lstStyle/>
-          <a:p>
-            <a:pPr algn="ctr"/>
-          </a:p>
-        </p:txBody>
-      </p:sp>
-      <p:sp>
-        <p:nvSpPr>
-          <p:cNvPr id="19" name="TextBox 18"/>
-          <p:cNvSpPr txBox="1"/>
-          <p:nvPr/>
-        </p:nvSpPr>
-        <p:spPr>
-          <a:xfrm>
-            <a:off x="731520" y="5870448"/>
-            <a:ext cx="10789920" cy="457200"/>
-          </a:xfrm>
-          <a:prstGeom prst="rect">
-            <a:avLst/>
-          </a:prstGeom>
-          <a:noFill/>
-        </p:spPr>
-        <p:txBody>
-          <a:bodyPr wrap="square">
-            <a:spAutoFit/>
-          </a:bodyPr>
-          <a:lstStyle/>
-          <a:p>
-            <a:pPr algn="ctr"/>
-            <a:r>
-              <a:rPr sz="1500" b="1">
-                <a:solidFill>
-                  <a:srgbClr val="00FF9D"/>
-                </a:solidFill>
-              </a:rPr>
-              <a:t>✅  Not a prototype. Not a mockup. A real, production-deployed application.</a:t>
-            </a:r>
-          </a:p>
-        </p:txBody>
-      </p:sp>
-    </p:spTree>
-  </p:cSld>
-  <p:clrMapOvr>
-    <a:masterClrMapping/>
-  </p:clrMapOvr>
-</p:sld>
-</file>
-
-<file path=ppt/slides/slide12.xml><?xml version="1.0" encoding="utf-8"?>
-<p:sld xmlns:a="http://schemas.openxmlformats.org/drawingml/2006/main" xmlns:p="http://schemas.openxmlformats.org/presentationml/2006/main" xmlns:r="http://schemas.openxmlformats.org/officeDocument/2006/relationships">
-  <p:cSld>
-    <p:spTree>
-      <p:nvGrpSpPr>
-        <p:cNvPr id="1" name=""/>
-        <p:cNvGrpSpPr/>
-        <p:nvPr/>
-      </p:nvGrpSpPr>
-      <p:grpSpPr/>
-      <p:sp>
-        <p:nvSpPr>
-          <p:cNvPr id="2" name="Rectangle 1"/>
-          <p:cNvSpPr/>
-          <p:nvPr/>
-        </p:nvSpPr>
-        <p:spPr>
-          <a:xfrm>
-            <a:off x="0" y="0"/>
-            <a:ext cx="12188952" cy="6858000"/>
-          </a:xfrm>
-          <a:prstGeom prst="rect">
-            <a:avLst/>
-          </a:prstGeom>
-          <a:solidFill>
-            <a:srgbClr val="0D1017"/>
-          </a:solidFill>
-          <a:ln>
-            <a:noFill/>
-          </a:ln>
-        </p:spPr>
-        <p:style>
-          <a:lnRef idx="1">
-            <a:schemeClr val="accent1"/>
-          </a:lnRef>
-          <a:fillRef idx="3">
-            <a:schemeClr val="accent1"/>
-          </a:fillRef>
-          <a:effectRef idx="2">
-            <a:schemeClr val="accent1"/>
-          </a:effectRef>
-          <a:fontRef idx="minor">
-            <a:schemeClr val="lt1"/>
-          </a:fontRef>
-        </p:style>
-        <p:txBody>
-          <a:bodyPr rtlCol="0" anchor="ctr"/>
-          <a:lstStyle/>
-          <a:p>
-            <a:pPr algn="ctr"/>
-          </a:p>
-        </p:txBody>
-      </p:sp>
-      <p:sp>
-        <p:nvSpPr>
-          <p:cNvPr id="3" name="Rectangle 2"/>
-          <p:cNvSpPr/>
-          <p:nvPr/>
-        </p:nvSpPr>
-        <p:spPr>
-          <a:xfrm>
-            <a:off x="0" y="0"/>
-            <a:ext cx="12188952" cy="73152"/>
-          </a:xfrm>
-          <a:prstGeom prst="rect">
-            <a:avLst/>
-          </a:prstGeom>
-          <a:solidFill>
-            <a:srgbClr val="00D4FF"/>
-          </a:solidFill>
-          <a:ln>
-            <a:noFill/>
-          </a:ln>
-        </p:spPr>
-        <p:style>
-          <a:lnRef idx="1">
-            <a:schemeClr val="accent1"/>
-          </a:lnRef>
-          <a:fillRef idx="3">
-            <a:schemeClr val="accent1"/>
-          </a:fillRef>
-          <a:effectRef idx="2">
-            <a:schemeClr val="accent1"/>
-          </a:effectRef>
-          <a:fontRef idx="minor">
-            <a:schemeClr val="lt1"/>
-          </a:fontRef>
-        </p:style>
-        <p:txBody>
-          <a:bodyPr rtlCol="0" anchor="ctr"/>
-          <a:lstStyle/>
-          <a:p>
-            <a:pPr algn="ctr"/>
-          </a:p>
-        </p:txBody>
-      </p:sp>
-      <p:sp>
-        <p:nvSpPr>
-          <p:cNvPr id="4" name="Rectangle 3"/>
-          <p:cNvSpPr/>
-          <p:nvPr/>
-        </p:nvSpPr>
-        <p:spPr>
-          <a:xfrm>
-            <a:off x="0" y="6784848"/>
-            <a:ext cx="12188952" cy="73152"/>
-          </a:xfrm>
-          <a:prstGeom prst="rect">
-            <a:avLst/>
-          </a:prstGeom>
-          <a:solidFill>
-            <a:srgbClr val="00D4FF"/>
-          </a:solidFill>
-          <a:ln>
-            <a:noFill/>
-          </a:ln>
-        </p:spPr>
-        <p:style>
-          <a:lnRef idx="1">
-            <a:schemeClr val="accent1"/>
-          </a:lnRef>
-          <a:fillRef idx="3">
-            <a:schemeClr val="accent1"/>
-          </a:fillRef>
-          <a:effectRef idx="2">
-            <a:schemeClr val="accent1"/>
-          </a:effectRef>
-          <a:fontRef idx="minor">
-            <a:schemeClr val="lt1"/>
-          </a:fontRef>
-        </p:style>
-        <p:txBody>
-          <a:bodyPr rtlCol="0" anchor="ctr"/>
-          <a:lstStyle/>
-          <a:p>
-            <a:pPr algn="ctr"/>
-          </a:p>
-        </p:txBody>
-      </p:sp>
-      <p:sp>
-        <p:nvSpPr>
-          <p:cNvPr id="5" name="TextBox 4"/>
-          <p:cNvSpPr txBox="1"/>
-          <p:nvPr/>
-        </p:nvSpPr>
-        <p:spPr>
-          <a:xfrm>
             <a:off x="1371600" y="1188720"/>
             <a:ext cx="9144000" cy="1280160"/>
           </a:xfrm>
@@ -5050,7 +4275,7 @@
                   <a:srgbClr val="00D4FF"/>
                 </a:solidFill>
               </a:rPr>
-              <a:t>The Brain Every Pharmacy is Missing</a:t>
+              <a:t>The Brain Every Business is Missing</a:t>
             </a:r>
           </a:p>
         </p:txBody>
@@ -5106,28 +4331,28 @@
         </p:nvSpPr>
         <p:spPr>
           <a:xfrm>
-            <a:off x="2286000" y="3657600"/>
-            <a:ext cx="7589520" cy="457200"/>
-          </a:xfrm>
-          <a:prstGeom prst="rect">
-            <a:avLst/>
-          </a:prstGeom>
-          <a:noFill/>
-        </p:spPr>
-        <p:txBody>
-          <a:bodyPr wrap="square">
-            <a:spAutoFit/>
-          </a:bodyPr>
-          <a:lstStyle/>
-          <a:p>
-            <a:pPr algn="ctr"/>
-            <a:r>
-              <a:rPr sz="1600" b="0">
+            <a:off x="1828800" y="3657600"/>
+            <a:ext cx="8503920" cy="457200"/>
+          </a:xfrm>
+          <a:prstGeom prst="rect">
+            <a:avLst/>
+          </a:prstGeom>
+          <a:noFill/>
+        </p:spPr>
+        <p:txBody>
+          <a:bodyPr wrap="square">
+            <a:spAutoFit/>
+          </a:bodyPr>
+          <a:lstStyle/>
+          <a:p>
+            <a:pPr algn="ctr"/>
+            <a:r>
+              <a:rPr sz="1500" b="0">
                 <a:solidFill>
                   <a:srgbClr val="B0BEC5"/>
                 </a:solidFill>
               </a:rPr>
-              <a:t>🔮  Predict demand before stock runs out</a:t>
+              <a:t>🔮  Predict demand before stock runs out — any product, any category</a:t>
             </a:r>
           </a:p>
         </p:txBody>
@@ -5140,28 +4365,28 @@
         </p:nvSpPr>
         <p:spPr>
           <a:xfrm>
-            <a:off x="2286000" y="4160520"/>
-            <a:ext cx="7589520" cy="457200"/>
-          </a:xfrm>
-          <a:prstGeom prst="rect">
-            <a:avLst/>
-          </a:prstGeom>
-          <a:noFill/>
-        </p:spPr>
-        <p:txBody>
-          <a:bodyPr wrap="square">
-            <a:spAutoFit/>
-          </a:bodyPr>
-          <a:lstStyle/>
-          <a:p>
-            <a:pPr algn="ctr"/>
-            <a:r>
-              <a:rPr sz="1600" b="0">
+            <a:off x="1828800" y="4160520"/>
+            <a:ext cx="8503920" cy="457200"/>
+          </a:xfrm>
+          <a:prstGeom prst="rect">
+            <a:avLst/>
+          </a:prstGeom>
+          <a:noFill/>
+        </p:spPr>
+        <p:txBody>
+          <a:bodyPr wrap="square">
+            <a:spAutoFit/>
+          </a:bodyPr>
+          <a:lstStyle/>
+          <a:p>
+            <a:pPr algn="ctr"/>
+            <a:r>
+              <a:rPr sz="1500" b="0">
                 <a:solidFill>
                   <a:srgbClr val="B0BEC5"/>
                 </a:solidFill>
               </a:rPr>
-              <a:t>🚨  Get plain-English alerts — not numbers</a:t>
+              <a:t>🚨  Get plain-English alerts — not numbers, not reports</a:t>
             </a:r>
           </a:p>
         </p:txBody>
@@ -5174,28 +4399,28 @@
         </p:nvSpPr>
         <p:spPr>
           <a:xfrm>
-            <a:off x="2286000" y="4663440"/>
-            <a:ext cx="7589520" cy="457200"/>
-          </a:xfrm>
-          <a:prstGeom prst="rect">
-            <a:avLst/>
-          </a:prstGeom>
-          <a:noFill/>
-        </p:spPr>
-        <p:txBody>
-          <a:bodyPr wrap="square">
-            <a:spAutoFit/>
-          </a:bodyPr>
-          <a:lstStyle/>
-          <a:p>
-            <a:pPr algn="ctr"/>
-            <a:r>
-              <a:rPr sz="1600" b="0">
+            <a:off x="1828800" y="4663440"/>
+            <a:ext cx="8503920" cy="457200"/>
+          </a:xfrm>
+          <a:prstGeom prst="rect">
+            <a:avLst/>
+          </a:prstGeom>
+          <a:noFill/>
+        </p:spPr>
+        <p:txBody>
+          <a:bodyPr wrap="square">
+            <a:spAutoFit/>
+          </a:bodyPr>
+          <a:lstStyle/>
+          <a:p>
+            <a:pPr algn="ctr"/>
+            <a:r>
+              <a:rPr sz="1500" b="0">
                 <a:solidFill>
                   <a:srgbClr val="B0BEC5"/>
                 </a:solidFill>
               </a:rPr>
-              <a:t>📊  See real analytics from real sales data</a:t>
+              <a:t>📊  See real analytics from real sales data — automatically</a:t>
             </a:r>
           </a:p>
         </p:txBody>
@@ -5208,28 +4433,28 @@
         </p:nvSpPr>
         <p:spPr>
           <a:xfrm>
-            <a:off x="2286000" y="5166360"/>
-            <a:ext cx="7589520" cy="457200"/>
-          </a:xfrm>
-          <a:prstGeom prst="rect">
-            <a:avLst/>
-          </a:prstGeom>
-          <a:noFill/>
-        </p:spPr>
-        <p:txBody>
-          <a:bodyPr wrap="square">
-            <a:spAutoFit/>
-          </a:bodyPr>
-          <a:lstStyle/>
-          <a:p>
-            <a:pPr algn="ctr"/>
-            <a:r>
-              <a:rPr sz="1600" b="0">
+            <a:off x="1828800" y="5166360"/>
+            <a:ext cx="8503920" cy="457200"/>
+          </a:xfrm>
+          <a:prstGeom prst="rect">
+            <a:avLst/>
+          </a:prstGeom>
+          <a:noFill/>
+        </p:spPr>
+        <p:txBody>
+          <a:bodyPr wrap="square">
+            <a:spAutoFit/>
+          </a:bodyPr>
+          <a:lstStyle/>
+          <a:p>
+            <a:pPr algn="ctr"/>
+            <a:r>
+              <a:rPr sz="1500" b="0">
                 <a:solidFill>
                   <a:srgbClr val="B0BEC5"/>
                 </a:solidFill>
               </a:rPr>
-              <a:t>☁️  Live on cloud — works anywhere, anytime</a:t>
+              <a:t>☁️  One platform for Pharmacy, Grocery, Retail, Electronics &amp; more</a:t>
             </a:r>
           </a:p>
         </p:txBody>
@@ -5623,7 +4848,7 @@
                   <a:srgbClr val="B0BEC5"/>
                 </a:solidFill>
               </a:rPr>
-              <a:t>Produces medicines
+              <a:t>Produces goods
 in bulk</a:t>
             </a:r>
           </a:p>
@@ -6198,7 +5423,7 @@
                   <a:srgbClr val="B0BEC5"/>
                 </a:solidFill>
               </a:rPr>
-              <a:t>Each link in the chain depends on accurate inventory data to function efficiently.</a:t>
+              <a:t>Applies to every business — Pharmacy, Grocery, Retail, Electronics, Restaurant &amp; more.</a:t>
             </a:r>
           </a:p>
         </p:txBody>
@@ -6524,7 +5749,7 @@
                   <a:srgbClr val="B0BEC5"/>
                 </a:solidFill>
               </a:rPr>
-              <a:t>Companies can't predict demand → overstock or stockout</a:t>
+              <a:t>Businesses can't predict demand → overstock or stockout — affects every sector</a:t>
             </a:r>
           </a:p>
         </p:txBody>
@@ -6601,7 +5826,7 @@
                   <a:srgbClr val="FF3D3D"/>
                 </a:solidFill>
               </a:rPr>
-              <a:t>🗑️  Waste &amp; Expiry</a:t>
+              <a:t>🗑️  Waste &amp; Dead Stock</a:t>
             </a:r>
           </a:p>
         </p:txBody>
@@ -6635,7 +5860,7 @@
                   <a:srgbClr val="B0BEC5"/>
                 </a:solidFill>
               </a:rPr>
-              <a:t>Medicines expire on shelves → ₹15,000+ annual loss per pharmacy</a:t>
+              <a:t>Perishables, medicines, seasonal goods expire → ₹15,000+ loss per shop per year</a:t>
             </a:r>
           </a:p>
         </p:txBody>
@@ -6712,7 +5937,7 @@
                   <a:srgbClr val="FF3D3D"/>
                 </a:solidFill>
               </a:rPr>
-              <a:t>🔗  Poor Visibility</a:t>
+              <a:t>🔗  No Real-Time Visibility</a:t>
             </a:r>
           </a:p>
         </p:txBody>
@@ -6746,7 +5971,7 @@
                   <a:srgbClr val="B0BEC5"/>
                 </a:solidFill>
               </a:rPr>
-              <a:t>No real-time view of stock levels across the chain</a:t>
+              <a:t>No live view of stock levels — owners fly blind across all product categories</a:t>
             </a:r>
           </a:p>
         </p:txBody>
@@ -6857,7 +6082,7 @@
                   <a:srgbClr val="B0BEC5"/>
                 </a:solidFill>
               </a:rPr>
-              <a:t>Paper ledgers &amp; Excel → errors, delays, data loss</a:t>
+              <a:t>Paper ledgers &amp; Excel → errors, delays, data loss in grocery, retail &amp; pharmacy alike</a:t>
             </a:r>
           </a:p>
         </p:txBody>
@@ -6934,7 +6159,7 @@
                   <a:srgbClr val="FF3D3D"/>
                 </a:solidFill>
               </a:rPr>
-              <a:t>💸  Cash Flow Issues</a:t>
+              <a:t>💸  Cash Flow Locked in Dead Stock</a:t>
             </a:r>
           </a:p>
         </p:txBody>
@@ -6968,7 +6193,7 @@
                   <a:srgbClr val="B0BEC5"/>
                 </a:solidFill>
               </a:rPr>
-              <a:t>Dead stock locks up capital that could be reinvested</a:t>
+              <a:t>Overstocked products tie up capital that every small business desperately needs</a:t>
             </a:r>
           </a:p>
         </p:txBody>
@@ -7045,7 +6270,7 @@
                   <a:srgbClr val="FF3D3D"/>
                 </a:solidFill>
               </a:rPr>
-              <a:t>⏰  Reactive Decisions</a:t>
+              <a:t>⏰  Reactive Decisions Only</a:t>
             </a:r>
           </a:p>
         </p:txBody>
@@ -7079,7 +6304,7 @@
                   <a:srgbClr val="B0BEC5"/>
                 </a:solidFill>
               </a:rPr>
-              <a:t>Owners reorder only when stock runs out — too late!</a:t>
+              <a:t>Owners in every industry reorder only after running out — always one step behind</a:t>
             </a:r>
           </a:p>
         </p:txBody>
@@ -7260,7 +6485,7 @@
                   <a:srgbClr val="FFFFFF"/>
                 </a:solidFill>
               </a:rPr>
-              <a:t>The Pharmacy Owner's Daily Nightmare</a:t>
+              <a:t>The Small Business Owner's Daily Nightmare</a:t>
             </a:r>
           </a:p>
         </p:txBody>
@@ -7273,8 +6498,470 @@
         </p:nvSpPr>
         <p:spPr>
           <a:xfrm>
-            <a:off x="502920" y="1463040"/>
-            <a:ext cx="2606040" cy="1737360"/>
+            <a:off x="502920" y="1234440"/>
+            <a:ext cx="1737360" cy="502920"/>
+          </a:xfrm>
+          <a:prstGeom prst="rect">
+            <a:avLst/>
+          </a:prstGeom>
+          <a:solidFill>
+            <a:srgbClr val="221404"/>
+          </a:solidFill>
+          <a:ln>
+            <a:noFill/>
+          </a:ln>
+        </p:spPr>
+        <p:style>
+          <a:lnRef idx="1">
+            <a:schemeClr val="accent1"/>
+          </a:lnRef>
+          <a:fillRef idx="3">
+            <a:schemeClr val="accent1"/>
+          </a:fillRef>
+          <a:effectRef idx="2">
+            <a:schemeClr val="accent1"/>
+          </a:effectRef>
+          <a:fontRef idx="minor">
+            <a:schemeClr val="lt1"/>
+          </a:fontRef>
+        </p:style>
+        <p:txBody>
+          <a:bodyPr rtlCol="0" anchor="ctr"/>
+          <a:lstStyle/>
+          <a:p>
+            <a:pPr algn="ctr"/>
+          </a:p>
+        </p:txBody>
+      </p:sp>
+      <p:sp>
+        <p:nvSpPr>
+          <p:cNvPr id="7" name="TextBox 6"/>
+          <p:cNvSpPr txBox="1"/>
+          <p:nvPr/>
+        </p:nvSpPr>
+        <p:spPr>
+          <a:xfrm>
+            <a:off x="594360" y="1307592"/>
+            <a:ext cx="1572768" cy="347472"/>
+          </a:xfrm>
+          <a:prstGeom prst="rect">
+            <a:avLst/>
+          </a:prstGeom>
+          <a:noFill/>
+        </p:spPr>
+        <p:txBody>
+          <a:bodyPr wrap="square">
+            <a:spAutoFit/>
+          </a:bodyPr>
+          <a:lstStyle/>
+          <a:p>
+            <a:pPr algn="ctr"/>
+            <a:r>
+              <a:rPr sz="1300" b="1">
+                <a:solidFill>
+                  <a:srgbClr val="FF6B35"/>
+                </a:solidFill>
+              </a:rPr>
+              <a:t>💊 Pharmacy</a:t>
+            </a:r>
+          </a:p>
+        </p:txBody>
+      </p:sp>
+      <p:sp>
+        <p:nvSpPr>
+          <p:cNvPr id="8" name="Rectangle 7"/>
+          <p:cNvSpPr/>
+          <p:nvPr/>
+        </p:nvSpPr>
+        <p:spPr>
+          <a:xfrm>
+            <a:off x="2468880" y="1234440"/>
+            <a:ext cx="1737360" cy="502920"/>
+          </a:xfrm>
+          <a:prstGeom prst="rect">
+            <a:avLst/>
+          </a:prstGeom>
+          <a:solidFill>
+            <a:srgbClr val="221404"/>
+          </a:solidFill>
+          <a:ln>
+            <a:noFill/>
+          </a:ln>
+        </p:spPr>
+        <p:style>
+          <a:lnRef idx="1">
+            <a:schemeClr val="accent1"/>
+          </a:lnRef>
+          <a:fillRef idx="3">
+            <a:schemeClr val="accent1"/>
+          </a:fillRef>
+          <a:effectRef idx="2">
+            <a:schemeClr val="accent1"/>
+          </a:effectRef>
+          <a:fontRef idx="minor">
+            <a:schemeClr val="lt1"/>
+          </a:fontRef>
+        </p:style>
+        <p:txBody>
+          <a:bodyPr rtlCol="0" anchor="ctr"/>
+          <a:lstStyle/>
+          <a:p>
+            <a:pPr algn="ctr"/>
+          </a:p>
+        </p:txBody>
+      </p:sp>
+      <p:sp>
+        <p:nvSpPr>
+          <p:cNvPr id="9" name="TextBox 8"/>
+          <p:cNvSpPr txBox="1"/>
+          <p:nvPr/>
+        </p:nvSpPr>
+        <p:spPr>
+          <a:xfrm>
+            <a:off x="2560320" y="1307592"/>
+            <a:ext cx="1572768" cy="347472"/>
+          </a:xfrm>
+          <a:prstGeom prst="rect">
+            <a:avLst/>
+          </a:prstGeom>
+          <a:noFill/>
+        </p:spPr>
+        <p:txBody>
+          <a:bodyPr wrap="square">
+            <a:spAutoFit/>
+          </a:bodyPr>
+          <a:lstStyle/>
+          <a:p>
+            <a:pPr algn="ctr"/>
+            <a:r>
+              <a:rPr sz="1300" b="1">
+                <a:solidFill>
+                  <a:srgbClr val="FF6B35"/>
+                </a:solidFill>
+              </a:rPr>
+              <a:t>🛒 Grocery</a:t>
+            </a:r>
+          </a:p>
+        </p:txBody>
+      </p:sp>
+      <p:sp>
+        <p:nvSpPr>
+          <p:cNvPr id="10" name="Rectangle 9"/>
+          <p:cNvSpPr/>
+          <p:nvPr/>
+        </p:nvSpPr>
+        <p:spPr>
+          <a:xfrm>
+            <a:off x="4434840" y="1234440"/>
+            <a:ext cx="1737360" cy="502920"/>
+          </a:xfrm>
+          <a:prstGeom prst="rect">
+            <a:avLst/>
+          </a:prstGeom>
+          <a:solidFill>
+            <a:srgbClr val="221404"/>
+          </a:solidFill>
+          <a:ln>
+            <a:noFill/>
+          </a:ln>
+        </p:spPr>
+        <p:style>
+          <a:lnRef idx="1">
+            <a:schemeClr val="accent1"/>
+          </a:lnRef>
+          <a:fillRef idx="3">
+            <a:schemeClr val="accent1"/>
+          </a:fillRef>
+          <a:effectRef idx="2">
+            <a:schemeClr val="accent1"/>
+          </a:effectRef>
+          <a:fontRef idx="minor">
+            <a:schemeClr val="lt1"/>
+          </a:fontRef>
+        </p:style>
+        <p:txBody>
+          <a:bodyPr rtlCol="0" anchor="ctr"/>
+          <a:lstStyle/>
+          <a:p>
+            <a:pPr algn="ctr"/>
+          </a:p>
+        </p:txBody>
+      </p:sp>
+      <p:sp>
+        <p:nvSpPr>
+          <p:cNvPr id="11" name="TextBox 10"/>
+          <p:cNvSpPr txBox="1"/>
+          <p:nvPr/>
+        </p:nvSpPr>
+        <p:spPr>
+          <a:xfrm>
+            <a:off x="4526279" y="1307592"/>
+            <a:ext cx="1572768" cy="347472"/>
+          </a:xfrm>
+          <a:prstGeom prst="rect">
+            <a:avLst/>
+          </a:prstGeom>
+          <a:noFill/>
+        </p:spPr>
+        <p:txBody>
+          <a:bodyPr wrap="square">
+            <a:spAutoFit/>
+          </a:bodyPr>
+          <a:lstStyle/>
+          <a:p>
+            <a:pPr algn="ctr"/>
+            <a:r>
+              <a:rPr sz="1300" b="1">
+                <a:solidFill>
+                  <a:srgbClr val="FF6B35"/>
+                </a:solidFill>
+              </a:rPr>
+              <a:t>👗 Retail</a:t>
+            </a:r>
+          </a:p>
+        </p:txBody>
+      </p:sp>
+      <p:sp>
+        <p:nvSpPr>
+          <p:cNvPr id="12" name="Rectangle 11"/>
+          <p:cNvSpPr/>
+          <p:nvPr/>
+        </p:nvSpPr>
+        <p:spPr>
+          <a:xfrm>
+            <a:off x="6400799" y="1234440"/>
+            <a:ext cx="1737360" cy="502920"/>
+          </a:xfrm>
+          <a:prstGeom prst="rect">
+            <a:avLst/>
+          </a:prstGeom>
+          <a:solidFill>
+            <a:srgbClr val="221404"/>
+          </a:solidFill>
+          <a:ln>
+            <a:noFill/>
+          </a:ln>
+        </p:spPr>
+        <p:style>
+          <a:lnRef idx="1">
+            <a:schemeClr val="accent1"/>
+          </a:lnRef>
+          <a:fillRef idx="3">
+            <a:schemeClr val="accent1"/>
+          </a:fillRef>
+          <a:effectRef idx="2">
+            <a:schemeClr val="accent1"/>
+          </a:effectRef>
+          <a:fontRef idx="minor">
+            <a:schemeClr val="lt1"/>
+          </a:fontRef>
+        </p:style>
+        <p:txBody>
+          <a:bodyPr rtlCol="0" anchor="ctr"/>
+          <a:lstStyle/>
+          <a:p>
+            <a:pPr algn="ctr"/>
+          </a:p>
+        </p:txBody>
+      </p:sp>
+      <p:sp>
+        <p:nvSpPr>
+          <p:cNvPr id="13" name="TextBox 12"/>
+          <p:cNvSpPr txBox="1"/>
+          <p:nvPr/>
+        </p:nvSpPr>
+        <p:spPr>
+          <a:xfrm>
+            <a:off x="6492239" y="1307592"/>
+            <a:ext cx="1572768" cy="347472"/>
+          </a:xfrm>
+          <a:prstGeom prst="rect">
+            <a:avLst/>
+          </a:prstGeom>
+          <a:noFill/>
+        </p:spPr>
+        <p:txBody>
+          <a:bodyPr wrap="square">
+            <a:spAutoFit/>
+          </a:bodyPr>
+          <a:lstStyle/>
+          <a:p>
+            <a:pPr algn="ctr"/>
+            <a:r>
+              <a:rPr sz="1300" b="1">
+                <a:solidFill>
+                  <a:srgbClr val="FF6B35"/>
+                </a:solidFill>
+              </a:rPr>
+              <a:t>📱 Electronics</a:t>
+            </a:r>
+          </a:p>
+        </p:txBody>
+      </p:sp>
+      <p:sp>
+        <p:nvSpPr>
+          <p:cNvPr id="14" name="Rectangle 13"/>
+          <p:cNvSpPr/>
+          <p:nvPr/>
+        </p:nvSpPr>
+        <p:spPr>
+          <a:xfrm>
+            <a:off x="8366760" y="1234440"/>
+            <a:ext cx="1737360" cy="502920"/>
+          </a:xfrm>
+          <a:prstGeom prst="rect">
+            <a:avLst/>
+          </a:prstGeom>
+          <a:solidFill>
+            <a:srgbClr val="221404"/>
+          </a:solidFill>
+          <a:ln>
+            <a:noFill/>
+          </a:ln>
+        </p:spPr>
+        <p:style>
+          <a:lnRef idx="1">
+            <a:schemeClr val="accent1"/>
+          </a:lnRef>
+          <a:fillRef idx="3">
+            <a:schemeClr val="accent1"/>
+          </a:fillRef>
+          <a:effectRef idx="2">
+            <a:schemeClr val="accent1"/>
+          </a:effectRef>
+          <a:fontRef idx="minor">
+            <a:schemeClr val="lt1"/>
+          </a:fontRef>
+        </p:style>
+        <p:txBody>
+          <a:bodyPr rtlCol="0" anchor="ctr"/>
+          <a:lstStyle/>
+          <a:p>
+            <a:pPr algn="ctr"/>
+          </a:p>
+        </p:txBody>
+      </p:sp>
+      <p:sp>
+        <p:nvSpPr>
+          <p:cNvPr id="15" name="TextBox 14"/>
+          <p:cNvSpPr txBox="1"/>
+          <p:nvPr/>
+        </p:nvSpPr>
+        <p:spPr>
+          <a:xfrm>
+            <a:off x="8458200" y="1307592"/>
+            <a:ext cx="1572768" cy="347472"/>
+          </a:xfrm>
+          <a:prstGeom prst="rect">
+            <a:avLst/>
+          </a:prstGeom>
+          <a:noFill/>
+        </p:spPr>
+        <p:txBody>
+          <a:bodyPr wrap="square">
+            <a:spAutoFit/>
+          </a:bodyPr>
+          <a:lstStyle/>
+          <a:p>
+            <a:pPr algn="ctr"/>
+            <a:r>
+              <a:rPr sz="1300" b="1">
+                <a:solidFill>
+                  <a:srgbClr val="FF6B35"/>
+                </a:solidFill>
+              </a:rPr>
+              <a:t>🍽️ Restaurant</a:t>
+            </a:r>
+          </a:p>
+        </p:txBody>
+      </p:sp>
+      <p:sp>
+        <p:nvSpPr>
+          <p:cNvPr id="16" name="Rectangle 15"/>
+          <p:cNvSpPr/>
+          <p:nvPr/>
+        </p:nvSpPr>
+        <p:spPr>
+          <a:xfrm>
+            <a:off x="10332720" y="1234440"/>
+            <a:ext cx="1737360" cy="502920"/>
+          </a:xfrm>
+          <a:prstGeom prst="rect">
+            <a:avLst/>
+          </a:prstGeom>
+          <a:solidFill>
+            <a:srgbClr val="221404"/>
+          </a:solidFill>
+          <a:ln>
+            <a:noFill/>
+          </a:ln>
+        </p:spPr>
+        <p:style>
+          <a:lnRef idx="1">
+            <a:schemeClr val="accent1"/>
+          </a:lnRef>
+          <a:fillRef idx="3">
+            <a:schemeClr val="accent1"/>
+          </a:fillRef>
+          <a:effectRef idx="2">
+            <a:schemeClr val="accent1"/>
+          </a:effectRef>
+          <a:fontRef idx="minor">
+            <a:schemeClr val="lt1"/>
+          </a:fontRef>
+        </p:style>
+        <p:txBody>
+          <a:bodyPr rtlCol="0" anchor="ctr"/>
+          <a:lstStyle/>
+          <a:p>
+            <a:pPr algn="ctr"/>
+          </a:p>
+        </p:txBody>
+      </p:sp>
+      <p:sp>
+        <p:nvSpPr>
+          <p:cNvPr id="17" name="TextBox 16"/>
+          <p:cNvSpPr txBox="1"/>
+          <p:nvPr/>
+        </p:nvSpPr>
+        <p:spPr>
+          <a:xfrm>
+            <a:off x="10424160" y="1307592"/>
+            <a:ext cx="1572768" cy="347472"/>
+          </a:xfrm>
+          <a:prstGeom prst="rect">
+            <a:avLst/>
+          </a:prstGeom>
+          <a:noFill/>
+        </p:spPr>
+        <p:txBody>
+          <a:bodyPr wrap="square">
+            <a:spAutoFit/>
+          </a:bodyPr>
+          <a:lstStyle/>
+          <a:p>
+            <a:pPr algn="ctr"/>
+            <a:r>
+              <a:rPr sz="1300" b="1">
+                <a:solidFill>
+                  <a:srgbClr val="FF6B35"/>
+                </a:solidFill>
+              </a:rPr>
+              <a:t>📦 Wholesale</a:t>
+            </a:r>
+          </a:p>
+        </p:txBody>
+      </p:sp>
+      <p:sp>
+        <p:nvSpPr>
+          <p:cNvPr id="18" name="Rectangle 17"/>
+          <p:cNvSpPr/>
+          <p:nvPr/>
+        </p:nvSpPr>
+        <p:spPr>
+          <a:xfrm>
+            <a:off x="502920" y="2011680"/>
+            <a:ext cx="2606040" cy="1691640"/>
           </a:xfrm>
           <a:prstGeom prst="rect">
             <a:avLst/>
@@ -7310,13 +6997,13 @@
       </p:sp>
       <p:sp>
         <p:nvSpPr>
-          <p:cNvPr id="7" name="TextBox 6"/>
-          <p:cNvSpPr txBox="1"/>
-          <p:nvPr/>
-        </p:nvSpPr>
-        <p:spPr>
-          <a:xfrm>
-            <a:off x="640080" y="1600200"/>
+          <p:cNvPr id="19" name="TextBox 18"/>
+          <p:cNvSpPr txBox="1"/>
+          <p:nvPr/>
+        </p:nvSpPr>
+        <p:spPr>
+          <a:xfrm>
+            <a:off x="640080" y="2148840"/>
             <a:ext cx="2331720" cy="822960"/>
           </a:xfrm>
           <a:prstGeom prst="rect">
@@ -7332,25 +7019,25 @@
           <a:p>
             <a:pPr algn="ctr"/>
             <a:r>
-              <a:rPr sz="3800" b="1">
+              <a:rPr sz="3600" b="1">
                 <a:solidFill>
                   <a:srgbClr val="FF6B35"/>
                 </a:solidFill>
               </a:rPr>
-              <a:t>9 Lakh+</a:t>
-            </a:r>
-          </a:p>
-        </p:txBody>
-      </p:sp>
-      <p:sp>
-        <p:nvSpPr>
-          <p:cNvPr id="8" name="TextBox 7"/>
-          <p:cNvSpPr txBox="1"/>
-          <p:nvPr/>
-        </p:nvSpPr>
-        <p:spPr>
-          <a:xfrm>
-            <a:off x="640080" y="2377440"/>
+              <a:t>63 Lakh+</a:t>
+            </a:r>
+          </a:p>
+        </p:txBody>
+      </p:sp>
+      <p:sp>
+        <p:nvSpPr>
+          <p:cNvPr id="20" name="TextBox 19"/>
+          <p:cNvSpPr txBox="1"/>
+          <p:nvPr/>
+        </p:nvSpPr>
+        <p:spPr>
+          <a:xfrm>
+            <a:off x="640080" y="2926080"/>
             <a:ext cx="2331720" cy="640080"/>
           </a:xfrm>
           <a:prstGeom prst="rect">
@@ -7366,27 +7053,27 @@
           <a:p>
             <a:pPr algn="ctr"/>
             <a:r>
-              <a:rPr sz="1300" b="0">
+              <a:rPr sz="1200" b="0">
                 <a:solidFill>
                   <a:srgbClr val="B0BEC5"/>
                 </a:solidFill>
               </a:rPr>
-              <a:t>Licensed pharmacies
-in India</a:t>
-            </a:r>
-          </a:p>
-        </p:txBody>
-      </p:sp>
-      <p:sp>
-        <p:nvSpPr>
-          <p:cNvPr id="9" name="Rectangle 8"/>
+              <a:t>MSMEs in India
+with inventory problems</a:t>
+            </a:r>
+          </a:p>
+        </p:txBody>
+      </p:sp>
+      <p:sp>
+        <p:nvSpPr>
+          <p:cNvPr id="21" name="Rectangle 20"/>
           <p:cNvSpPr/>
           <p:nvPr/>
         </p:nvSpPr>
         <p:spPr>
           <a:xfrm>
-            <a:off x="3337560" y="1463040"/>
-            <a:ext cx="2606040" cy="1737360"/>
+            <a:off x="3337560" y="2011680"/>
+            <a:ext cx="2606040" cy="1691640"/>
           </a:xfrm>
           <a:prstGeom prst="rect">
             <a:avLst/>
@@ -7422,13 +7109,13 @@
       </p:sp>
       <p:sp>
         <p:nvSpPr>
-          <p:cNvPr id="10" name="TextBox 9"/>
-          <p:cNvSpPr txBox="1"/>
-          <p:nvPr/>
-        </p:nvSpPr>
-        <p:spPr>
-          <a:xfrm>
-            <a:off x="3474720" y="1600200"/>
+          <p:cNvPr id="22" name="TextBox 21"/>
+          <p:cNvSpPr txBox="1"/>
+          <p:nvPr/>
+        </p:nvSpPr>
+        <p:spPr>
+          <a:xfrm>
+            <a:off x="3474720" y="2148840"/>
             <a:ext cx="2331720" cy="822960"/>
           </a:xfrm>
           <a:prstGeom prst="rect">
@@ -7444,7 +7131,7 @@
           <a:p>
             <a:pPr algn="ctr"/>
             <a:r>
-              <a:rPr sz="3800" b="1">
+              <a:rPr sz="3600" b="1">
                 <a:solidFill>
                   <a:srgbClr val="FF6B35"/>
                 </a:solidFill>
@@ -7456,13 +7143,13 @@
       </p:sp>
       <p:sp>
         <p:nvSpPr>
-          <p:cNvPr id="11" name="TextBox 10"/>
-          <p:cNvSpPr txBox="1"/>
-          <p:nvPr/>
-        </p:nvSpPr>
-        <p:spPr>
-          <a:xfrm>
-            <a:off x="3474720" y="2377440"/>
+          <p:cNvPr id="23" name="TextBox 22"/>
+          <p:cNvSpPr txBox="1"/>
+          <p:nvPr/>
+        </p:nvSpPr>
+        <p:spPr>
+          <a:xfrm>
+            <a:off x="3474720" y="2926080"/>
             <a:ext cx="2331720" cy="640080"/>
           </a:xfrm>
           <a:prstGeom prst="rect">
@@ -7478,7 +7165,7 @@
           <a:p>
             <a:pPr algn="ctr"/>
             <a:r>
-              <a:rPr sz="1300" b="0">
+              <a:rPr sz="1200" b="0">
                 <a:solidFill>
                   <a:srgbClr val="B0BEC5"/>
                 </a:solidFill>
@@ -7491,14 +7178,14 @@
       </p:sp>
       <p:sp>
         <p:nvSpPr>
-          <p:cNvPr id="12" name="Rectangle 11"/>
+          <p:cNvPr id="24" name="Rectangle 23"/>
           <p:cNvSpPr/>
           <p:nvPr/>
         </p:nvSpPr>
         <p:spPr>
           <a:xfrm>
-            <a:off x="6172200" y="1463040"/>
-            <a:ext cx="2606040" cy="1737360"/>
+            <a:off x="6172200" y="2011680"/>
+            <a:ext cx="2606040" cy="1691640"/>
           </a:xfrm>
           <a:prstGeom prst="rect">
             <a:avLst/>
@@ -7534,13 +7221,13 @@
       </p:sp>
       <p:sp>
         <p:nvSpPr>
-          <p:cNvPr id="13" name="TextBox 12"/>
-          <p:cNvSpPr txBox="1"/>
-          <p:nvPr/>
-        </p:nvSpPr>
-        <p:spPr>
-          <a:xfrm>
-            <a:off x="6309360" y="1600200"/>
+          <p:cNvPr id="25" name="TextBox 24"/>
+          <p:cNvSpPr txBox="1"/>
+          <p:nvPr/>
+        </p:nvSpPr>
+        <p:spPr>
+          <a:xfrm>
+            <a:off x="6309360" y="2148840"/>
             <a:ext cx="2331720" cy="822960"/>
           </a:xfrm>
           <a:prstGeom prst="rect">
@@ -7556,25 +7243,25 @@
           <a:p>
             <a:pPr algn="ctr"/>
             <a:r>
-              <a:rPr sz="3800" b="1">
+              <a:rPr sz="3600" b="1">
                 <a:solidFill>
                   <a:srgbClr val="FF6B35"/>
                 </a:solidFill>
               </a:rPr>
-              <a:t>₹15,000</a:t>
-            </a:r>
-          </a:p>
-        </p:txBody>
-      </p:sp>
-      <p:sp>
-        <p:nvSpPr>
-          <p:cNvPr id="14" name="TextBox 13"/>
-          <p:cNvSpPr txBox="1"/>
-          <p:nvPr/>
-        </p:nvSpPr>
-        <p:spPr>
-          <a:xfrm>
-            <a:off x="6309360" y="2377440"/>
+              <a:t>₹20,000</a:t>
+            </a:r>
+          </a:p>
+        </p:txBody>
+      </p:sp>
+      <p:sp>
+        <p:nvSpPr>
+          <p:cNvPr id="26" name="TextBox 25"/>
+          <p:cNvSpPr txBox="1"/>
+          <p:nvPr/>
+        </p:nvSpPr>
+        <p:spPr>
+          <a:xfrm>
+            <a:off x="6309360" y="2926080"/>
             <a:ext cx="2331720" cy="640080"/>
           </a:xfrm>
           <a:prstGeom prst="rect">
@@ -7590,27 +7277,27 @@
           <a:p>
             <a:pPr algn="ctr"/>
             <a:r>
-              <a:rPr sz="1300" b="0">
+              <a:rPr sz="1200" b="0">
                 <a:solidFill>
                   <a:srgbClr val="B0BEC5"/>
                 </a:solidFill>
               </a:rPr>
-              <a:t>Lost per year to
-expired medicines</a:t>
-            </a:r>
-          </a:p>
-        </p:txBody>
-      </p:sp>
-      <p:sp>
-        <p:nvSpPr>
-          <p:cNvPr id="15" name="Rectangle 14"/>
+              <a:t>Average annual loss
+to dead/expired stock</a:t>
+            </a:r>
+          </a:p>
+        </p:txBody>
+      </p:sp>
+      <p:sp>
+        <p:nvSpPr>
+          <p:cNvPr id="27" name="Rectangle 26"/>
           <p:cNvSpPr/>
           <p:nvPr/>
         </p:nvSpPr>
         <p:spPr>
           <a:xfrm>
-            <a:off x="9006840" y="1463040"/>
-            <a:ext cx="2606040" cy="1737360"/>
+            <a:off x="9006840" y="2011680"/>
+            <a:ext cx="2606040" cy="1691640"/>
           </a:xfrm>
           <a:prstGeom prst="rect">
             <a:avLst/>
@@ -7646,13 +7333,13 @@
       </p:sp>
       <p:sp>
         <p:nvSpPr>
-          <p:cNvPr id="16" name="TextBox 15"/>
-          <p:cNvSpPr txBox="1"/>
-          <p:nvPr/>
-        </p:nvSpPr>
-        <p:spPr>
-          <a:xfrm>
-            <a:off x="9144000" y="1600200"/>
+          <p:cNvPr id="28" name="TextBox 27"/>
+          <p:cNvSpPr txBox="1"/>
+          <p:nvPr/>
+        </p:nvSpPr>
+        <p:spPr>
+          <a:xfrm>
+            <a:off x="9144000" y="2148840"/>
             <a:ext cx="2331720" cy="822960"/>
           </a:xfrm>
           <a:prstGeom prst="rect">
@@ -7668,7 +7355,7 @@
           <a:p>
             <a:pPr algn="ctr"/>
             <a:r>
-              <a:rPr sz="3800" b="1">
+              <a:rPr sz="3600" b="1">
                 <a:solidFill>
                   <a:srgbClr val="FF6B35"/>
                 </a:solidFill>
@@ -7680,13 +7367,13 @@
       </p:sp>
       <p:sp>
         <p:nvSpPr>
-          <p:cNvPr id="17" name="TextBox 16"/>
-          <p:cNvSpPr txBox="1"/>
-          <p:nvPr/>
-        </p:nvSpPr>
-        <p:spPr>
-          <a:xfrm>
-            <a:off x="9144000" y="2377440"/>
+          <p:cNvPr id="29" name="TextBox 28"/>
+          <p:cNvSpPr txBox="1"/>
+          <p:nvPr/>
+        </p:nvSpPr>
+        <p:spPr>
+          <a:xfrm>
+            <a:off x="9144000" y="2926080"/>
             <a:ext cx="2331720" cy="640080"/>
           </a:xfrm>
           <a:prstGeom prst="rect">
@@ -7702,7 +7389,7 @@
           <a:p>
             <a:pPr algn="ctr"/>
             <a:r>
-              <a:rPr sz="1300" b="0">
+              <a:rPr sz="1200" b="0">
                 <a:solidFill>
                   <a:srgbClr val="B0BEC5"/>
                 </a:solidFill>
@@ -7715,13 +7402,13 @@
       </p:sp>
       <p:sp>
         <p:nvSpPr>
-          <p:cNvPr id="18" name="Rectangle 17"/>
+          <p:cNvPr id="30" name="Rectangle 29"/>
           <p:cNvSpPr/>
           <p:nvPr/>
         </p:nvSpPr>
         <p:spPr>
           <a:xfrm>
-            <a:off x="548640" y="3520440"/>
+            <a:off x="548640" y="3977639"/>
             <a:ext cx="11064240" cy="1097280"/>
           </a:xfrm>
           <a:prstGeom prst="rect">
@@ -7758,13 +7445,13 @@
       </p:sp>
       <p:sp>
         <p:nvSpPr>
-          <p:cNvPr id="19" name="TextBox 18"/>
-          <p:cNvSpPr txBox="1"/>
-          <p:nvPr/>
-        </p:nvSpPr>
-        <p:spPr>
-          <a:xfrm>
-            <a:off x="822960" y="3611880"/>
+          <p:cNvPr id="31" name="TextBox 30"/>
+          <p:cNvSpPr txBox="1"/>
+          <p:nvPr/>
+        </p:nvSpPr>
+        <p:spPr>
+          <a:xfrm>
+            <a:off x="822960" y="4069080"/>
             <a:ext cx="2743200" cy="457200"/>
           </a:xfrm>
           <a:prstGeom prst="rect">
@@ -7792,13 +7479,13 @@
       </p:sp>
       <p:sp>
         <p:nvSpPr>
-          <p:cNvPr id="20" name="TextBox 19"/>
-          <p:cNvSpPr txBox="1"/>
-          <p:nvPr/>
-        </p:nvSpPr>
-        <p:spPr>
-          <a:xfrm>
-            <a:off x="3200400" y="3611880"/>
+          <p:cNvPr id="32" name="TextBox 31"/>
+          <p:cNvSpPr txBox="1"/>
+          <p:nvPr/>
+        </p:nvSpPr>
+        <p:spPr>
+          <a:xfrm>
+            <a:off x="3200400" y="4069080"/>
             <a:ext cx="8229600" cy="822960"/>
           </a:xfrm>
           <a:prstGeom prst="rect">
@@ -7814,26 +7501,26 @@
           <a:p>
             <a:pPr algn="l"/>
             <a:r>
-              <a:rPr sz="1500" b="0">
+              <a:rPr sz="1400" b="0">
                 <a:solidFill>
                   <a:srgbClr val="B0BEC5"/>
                 </a:solidFill>
               </a:rPr>
-              <a:t>"I ordered too much Paracetamol last month — half of it expired.
-This month I ran out of it in 2 days and lost 30 customers."</a:t>
-            </a:r>
-          </a:p>
-        </p:txBody>
-      </p:sp>
-      <p:sp>
-        <p:nvSpPr>
-          <p:cNvPr id="21" name="TextBox 20"/>
-          <p:cNvSpPr txBox="1"/>
-          <p:nvPr/>
-        </p:nvSpPr>
-        <p:spPr>
-          <a:xfrm>
-            <a:off x="640080" y="4846320"/>
+              <a:t>"I ordered too much stock last month — half of it expired or became dead stock.
+This month I ran out of my bestseller in 2 days and lost 30 customers."</a:t>
+            </a:r>
+          </a:p>
+        </p:txBody>
+      </p:sp>
+      <p:sp>
+        <p:nvSpPr>
+          <p:cNvPr id="33" name="TextBox 32"/>
+          <p:cNvSpPr txBox="1"/>
+          <p:nvPr/>
+        </p:nvSpPr>
+        <p:spPr>
+          <a:xfrm>
+            <a:off x="640080" y="5257800"/>
             <a:ext cx="10972800" cy="457200"/>
           </a:xfrm>
           <a:prstGeom prst="rect">
@@ -7849,12 +7536,12 @@
           <a:p>
             <a:pPr algn="l"/>
             <a:r>
-              <a:rPr sz="1700" b="1">
+              <a:rPr sz="1600" b="1">
                 <a:solidFill>
                   <a:srgbClr val="FFFFFF"/>
                 </a:solidFill>
               </a:rPr>
-              <a:t>This is not a rare story. This is every small pharmacy owner in India. Every month.</a:t>
+              <a:t>This is not just a pharmacy problem. This is every small business owner in India. Every month.</a:t>
             </a:r>
           </a:p>
         </p:txBody>
@@ -8069,7 +7756,7 @@
                   <a:srgbClr val="00D4FF"/>
                 </a:solidFill>
               </a:rPr>
-              <a:t>The AI Brain every pharmacy is missing</a:t>
+              <a:t>One platform. Every business. Zero stock surprises.</a:t>
             </a:r>
           </a:p>
         </p:txBody>
@@ -8180,7 +7867,7 @@
                   <a:srgbClr val="B0BEC5"/>
                 </a:solidFill>
               </a:rPr>
-              <a:t>6 mathematical models predict when you'll run out — before it happens</a:t>
+              <a:t>6 models predict when ANY product will run out — pharmacy, grocery, retail &amp; more</a:t>
             </a:r>
           </a:p>
         </p:txBody>
@@ -8291,7 +7978,7 @@
                   <a:srgbClr val="B0BEC5"/>
                 </a:solidFill>
               </a:rPr>
-              <a:t>"Your Paracetamol will last only 2 more days. Order NOW." — anyone can use this</a:t>
+              <a:t>"Your Rice stock will last only 2 more days. Order NOW." — works for any product</a:t>
             </a:r>
           </a:p>
         </p:txBody>
@@ -8513,7 +8200,7 @@
                   <a:srgbClr val="B0BEC5"/>
                 </a:solidFill>
               </a:rPr>
-              <a:t>Create invoices, auto-update inventory, track payments</a:t>
+              <a:t>Create invoices, auto-update inventory, track payments — for any category</a:t>
             </a:r>
           </a:p>
         </p:txBody>
@@ -8624,7 +8311,7 @@
                   <a:srgbClr val="B0BEC5"/>
                 </a:solidFill>
               </a:rPr>
-              <a:t>Digital credit ledger — credit sales + payments, always balanced</a:t>
+              <a:t>Digital credit ledger — works for every business that gives credit to customers</a:t>
             </a:r>
           </a:p>
         </p:txBody>
@@ -8701,7 +8388,7 @@
                   <a:srgbClr val="00D4FF"/>
                 </a:solidFill>
               </a:rPr>
-              <a:t>☁️  Cloud-First</a:t>
+              <a:t>☁️  Cloud-First &amp; Multi-User</a:t>
             </a:r>
           </a:p>
         </p:txBody>
@@ -8735,7 +8422,7 @@
                   <a:srgbClr val="B0BEC5"/>
                 </a:solidFill>
               </a:rPr>
-              <a:t>Works anywhere, multi-device, Supabase PostgreSQL — zero data loss</a:t>
+              <a:t>Any device, anywhere — one account per shop, Supabase PostgreSQL, zero data loss</a:t>
             </a:r>
           </a:p>
         </p:txBody>
@@ -12858,7 +12545,7 @@
                   <a:srgbClr val="B0BEC5"/>
                 </a:solidFill>
               </a:rPr>
-              <a:t>Setup Cost</a:t>
+              <a:t>Plain-English Alerts</a:t>
             </a:r>
           </a:p>
         </p:txBody>
@@ -12892,7 +12579,7 @@
                   <a:srgbClr val="FF3D3D"/>
                 </a:solidFill>
               </a:rPr>
-              <a:t>❌  ₹10,000-20,000/yr</a:t>
+              <a:t>❌  Only numbers/reports</a:t>
             </a:r>
           </a:p>
         </p:txBody>
@@ -12926,7 +12613,7 @@
                   <a:srgbClr val="00FF9D"/>
                 </a:solidFill>
               </a:rPr>
-              <a:t>✅  Free / ₹499/month</a:t>
+              <a:t>✅  'Order NOW — 2 days left'</a:t>
             </a:r>
           </a:p>
         </p:txBody>
@@ -13089,7 +12776,7 @@
                   <a:srgbClr val="B0BEC5"/>
                 </a:solidFill>
               </a:rPr>
-              <a:t>Plain-English Alerts</a:t>
+              <a:t>Cloud Database</a:t>
             </a:r>
           </a:p>
         </p:txBody>
@@ -13123,7 +12810,7 @@
                   <a:srgbClr val="FF3D3D"/>
                 </a:solidFill>
               </a:rPr>
-              <a:t>❌  Only numbers/reports</a:t>
+              <a:t>❌  Local PC only</a:t>
             </a:r>
           </a:p>
         </p:txBody>
@@ -13157,7 +12844,7 @@
                   <a:srgbClr val="00FF9D"/>
                 </a:solidFill>
               </a:rPr>
-              <a:t>✅  'Order NOW — 2 days left'</a:t>
+              <a:t>✅  Supabase PostgreSQL</a:t>
             </a:r>
           </a:p>
         </p:txBody>
@@ -13320,7 +13007,7 @@
                   <a:srgbClr val="B0BEC5"/>
                 </a:solidFill>
               </a:rPr>
-              <a:t>Cloud Database</a:t>
+              <a:t>Google Login</a:t>
             </a:r>
           </a:p>
         </p:txBody>
@@ -13354,7 +13041,7 @@
                   <a:srgbClr val="FF3D3D"/>
                 </a:solidFill>
               </a:rPr>
-              <a:t>❌  Local PC only</a:t>
+              <a:t>❌  Username+Password</a:t>
             </a:r>
           </a:p>
         </p:txBody>
@@ -13388,7 +13075,7 @@
                   <a:srgbClr val="00FF9D"/>
                 </a:solidFill>
               </a:rPr>
-              <a:t>✅  Supabase PostgreSQL</a:t>
+              <a:t>✅  One-click OAuth</a:t>
             </a:r>
           </a:p>
         </p:txBody>
@@ -13551,7 +13238,7 @@
                   <a:srgbClr val="B0BEC5"/>
                 </a:solidFill>
               </a:rPr>
-              <a:t>Google Login</a:t>
+              <a:t>Analytics Charts</a:t>
             </a:r>
           </a:p>
         </p:txBody>
@@ -13585,7 +13272,7 @@
                   <a:srgbClr val="FF3D3D"/>
                 </a:solidFill>
               </a:rPr>
-              <a:t>❌  Username+Password</a:t>
+              <a:t>❌  Export to Excel only</a:t>
             </a:r>
           </a:p>
         </p:txBody>
@@ -13619,7 +13306,7 @@
                   <a:srgbClr val="00FF9D"/>
                 </a:solidFill>
               </a:rPr>
-              <a:t>✅  One-click OAuth</a:t>
+              <a:t>✅  Live interactive charts</a:t>
             </a:r>
           </a:p>
         </p:txBody>
@@ -13782,7 +13469,7 @@
                   <a:srgbClr val="B0BEC5"/>
                 </a:solidFill>
               </a:rPr>
-              <a:t>Analytics Charts</a:t>
+              <a:t>Customer Khata</a:t>
             </a:r>
           </a:p>
         </p:txBody>
@@ -13816,7 +13503,7 @@
                   <a:srgbClr val="FF3D3D"/>
                 </a:solidFill>
               </a:rPr>
-              <a:t>❌  Export to Excel only</a:t>
+              <a:t>❌  Separate notebook</a:t>
             </a:r>
           </a:p>
         </p:txBody>
@@ -13830,237 +13517,6 @@
         <p:spPr>
           <a:xfrm>
             <a:off x="7772400" y="4983480"/>
-            <a:ext cx="3840480" cy="411480"/>
-          </a:xfrm>
-          <a:prstGeom prst="rect">
-            <a:avLst/>
-          </a:prstGeom>
-          <a:noFill/>
-        </p:spPr>
-        <p:txBody>
-          <a:bodyPr wrap="square">
-            <a:spAutoFit/>
-          </a:bodyPr>
-          <a:lstStyle/>
-          <a:p>
-            <a:pPr algn="l"/>
-            <a:r>
-              <a:rPr sz="1300" b="0">
-                <a:solidFill>
-                  <a:srgbClr val="00FF9D"/>
-                </a:solidFill>
-              </a:rPr>
-              <a:t>✅  Live interactive charts</a:t>
-            </a:r>
-          </a:p>
-        </p:txBody>
-      </p:sp>
-      <p:sp>
-        <p:nvSpPr>
-          <p:cNvPr id="48" name="Rectangle 47"/>
-          <p:cNvSpPr/>
-          <p:nvPr/>
-        </p:nvSpPr>
-        <p:spPr>
-          <a:xfrm>
-            <a:off x="457200" y="5486400"/>
-            <a:ext cx="3657600" cy="548640"/>
-          </a:xfrm>
-          <a:prstGeom prst="rect">
-            <a:avLst/>
-          </a:prstGeom>
-          <a:solidFill>
-            <a:srgbClr val="0D121E"/>
-          </a:solidFill>
-          <a:ln>
-            <a:noFill/>
-          </a:ln>
-        </p:spPr>
-        <p:style>
-          <a:lnRef idx="1">
-            <a:schemeClr val="accent1"/>
-          </a:lnRef>
-          <a:fillRef idx="3">
-            <a:schemeClr val="accent1"/>
-          </a:fillRef>
-          <a:effectRef idx="2">
-            <a:schemeClr val="accent1"/>
-          </a:effectRef>
-          <a:fontRef idx="minor">
-            <a:schemeClr val="lt1"/>
-          </a:fontRef>
-        </p:style>
-        <p:txBody>
-          <a:bodyPr rtlCol="0" anchor="ctr"/>
-          <a:lstStyle/>
-          <a:p>
-            <a:pPr algn="ctr"/>
-          </a:p>
-        </p:txBody>
-      </p:sp>
-      <p:sp>
-        <p:nvSpPr>
-          <p:cNvPr id="49" name="Rectangle 48"/>
-          <p:cNvSpPr/>
-          <p:nvPr/>
-        </p:nvSpPr>
-        <p:spPr>
-          <a:xfrm>
-            <a:off x="4160520" y="5486400"/>
-            <a:ext cx="3474720" cy="548640"/>
-          </a:xfrm>
-          <a:prstGeom prst="rect">
-            <a:avLst/>
-          </a:prstGeom>
-          <a:solidFill>
-            <a:srgbClr val="0D121E"/>
-          </a:solidFill>
-          <a:ln>
-            <a:noFill/>
-          </a:ln>
-        </p:spPr>
-        <p:style>
-          <a:lnRef idx="1">
-            <a:schemeClr val="accent1"/>
-          </a:lnRef>
-          <a:fillRef idx="3">
-            <a:schemeClr val="accent1"/>
-          </a:fillRef>
-          <a:effectRef idx="2">
-            <a:schemeClr val="accent1"/>
-          </a:effectRef>
-          <a:fontRef idx="minor">
-            <a:schemeClr val="lt1"/>
-          </a:fontRef>
-        </p:style>
-        <p:txBody>
-          <a:bodyPr rtlCol="0" anchor="ctr"/>
-          <a:lstStyle/>
-          <a:p>
-            <a:pPr algn="ctr"/>
-          </a:p>
-        </p:txBody>
-      </p:sp>
-      <p:sp>
-        <p:nvSpPr>
-          <p:cNvPr id="50" name="Rectangle 49"/>
-          <p:cNvSpPr/>
-          <p:nvPr/>
-        </p:nvSpPr>
-        <p:spPr>
-          <a:xfrm>
-            <a:off x="7680960" y="5486400"/>
-            <a:ext cx="4023360" cy="548640"/>
-          </a:xfrm>
-          <a:prstGeom prst="rect">
-            <a:avLst/>
-          </a:prstGeom>
-          <a:solidFill>
-            <a:srgbClr val="0D121E"/>
-          </a:solidFill>
-          <a:ln>
-            <a:noFill/>
-          </a:ln>
-        </p:spPr>
-        <p:style>
-          <a:lnRef idx="1">
-            <a:schemeClr val="accent1"/>
-          </a:lnRef>
-          <a:fillRef idx="3">
-            <a:schemeClr val="accent1"/>
-          </a:fillRef>
-          <a:effectRef idx="2">
-            <a:schemeClr val="accent1"/>
-          </a:effectRef>
-          <a:fontRef idx="minor">
-            <a:schemeClr val="lt1"/>
-          </a:fontRef>
-        </p:style>
-        <p:txBody>
-          <a:bodyPr rtlCol="0" anchor="ctr"/>
-          <a:lstStyle/>
-          <a:p>
-            <a:pPr algn="ctr"/>
-          </a:p>
-        </p:txBody>
-      </p:sp>
-      <p:sp>
-        <p:nvSpPr>
-          <p:cNvPr id="51" name="TextBox 50"/>
-          <p:cNvSpPr txBox="1"/>
-          <p:nvPr/>
-        </p:nvSpPr>
-        <p:spPr>
-          <a:xfrm>
-            <a:off x="548640" y="5577840"/>
-            <a:ext cx="3474720" cy="411480"/>
-          </a:xfrm>
-          <a:prstGeom prst="rect">
-            <a:avLst/>
-          </a:prstGeom>
-          <a:noFill/>
-        </p:spPr>
-        <p:txBody>
-          <a:bodyPr wrap="square">
-            <a:spAutoFit/>
-          </a:bodyPr>
-          <a:lstStyle/>
-          <a:p>
-            <a:pPr algn="l"/>
-            <a:r>
-              <a:rPr sz="1300" b="0">
-                <a:solidFill>
-                  <a:srgbClr val="B0BEC5"/>
-                </a:solidFill>
-              </a:rPr>
-              <a:t>Customer Khata</a:t>
-            </a:r>
-          </a:p>
-        </p:txBody>
-      </p:sp>
-      <p:sp>
-        <p:nvSpPr>
-          <p:cNvPr id="52" name="TextBox 51"/>
-          <p:cNvSpPr txBox="1"/>
-          <p:nvPr/>
-        </p:nvSpPr>
-        <p:spPr>
-          <a:xfrm>
-            <a:off x="4251960" y="5577840"/>
-            <a:ext cx="3291840" cy="411480"/>
-          </a:xfrm>
-          <a:prstGeom prst="rect">
-            <a:avLst/>
-          </a:prstGeom>
-          <a:noFill/>
-        </p:spPr>
-        <p:txBody>
-          <a:bodyPr wrap="square">
-            <a:spAutoFit/>
-          </a:bodyPr>
-          <a:lstStyle/>
-          <a:p>
-            <a:pPr algn="l"/>
-            <a:r>
-              <a:rPr sz="1300" b="0">
-                <a:solidFill>
-                  <a:srgbClr val="FF3D3D"/>
-                </a:solidFill>
-              </a:rPr>
-              <a:t>❌  Separate notebook</a:t>
-            </a:r>
-          </a:p>
-        </p:txBody>
-      </p:sp>
-      <p:sp>
-        <p:nvSpPr>
-          <p:cNvPr id="53" name="TextBox 52"/>
-          <p:cNvSpPr txBox="1"/>
-          <p:nvPr/>
-        </p:nvSpPr>
-        <p:spPr>
-          <a:xfrm>
-            <a:off x="7772400" y="5577840"/>
             <a:ext cx="3840480" cy="411480"/>
           </a:xfrm>
           <a:prstGeom prst="rect">

</xml_diff>